<commit_message>
Rename cover choices to type A and type B
</commit_message>
<xml_diff>
--- a/assets/visual-reference/cps-layout-reference.pptx
+++ b/assets/visual-reference/cps-layout-reference.pptx
@@ -2,21 +2,21 @@
 <file path=ppt/presentation.xml><?xml version="1.0" encoding="utf-8"?>
 <p:presentation xmlns:p="http://schemas.openxmlformats.org/presentationml/2006/main">
   <p:sldMasterIdLst>
-    <p:sldMasterId xmlns:r="http://schemas.openxmlformats.org/officeDocument/2006/relationships" id="2147483648" r:id="R6afb9b5c3b58425d"/>
+    <p:sldMasterId xmlns:r="http://schemas.openxmlformats.org/officeDocument/2006/relationships" id="2147483648" r:id="Re6bf419e38d844bd"/>
   </p:sldMasterIdLst>
   <p:notesMasterIdLst>
-    <p:notesMasterId xmlns:r="http://schemas.openxmlformats.org/officeDocument/2006/relationships" r:id="Rfc4ec5d54dd94939"/>
+    <p:notesMasterId xmlns:r="http://schemas.openxmlformats.org/officeDocument/2006/relationships" r:id="R1340836cdac34e99"/>
   </p:notesMasterIdLst>
   <p:sldIdLst>
-    <p:sldId xmlns:r="http://schemas.openxmlformats.org/officeDocument/2006/relationships" id="256" r:id="R04917e5f2fcf4e1b"/>
-    <p:sldId xmlns:r="http://schemas.openxmlformats.org/officeDocument/2006/relationships" id="257" r:id="Rf4282a9494fd4468"/>
-    <p:sldId xmlns:r="http://schemas.openxmlformats.org/officeDocument/2006/relationships" id="258" r:id="R130310c841bc4d1a"/>
-    <p:sldId xmlns:r="http://schemas.openxmlformats.org/officeDocument/2006/relationships" id="259" r:id="R643b5968f54f4242"/>
-    <p:sldId xmlns:r="http://schemas.openxmlformats.org/officeDocument/2006/relationships" id="260" r:id="R45b75f5ec5b04994"/>
-    <p:sldId xmlns:r="http://schemas.openxmlformats.org/officeDocument/2006/relationships" id="261" r:id="Rdbd1a9ca7a084513"/>
-    <p:sldId xmlns:r="http://schemas.openxmlformats.org/officeDocument/2006/relationships" id="262" r:id="Rb530451ed46c4dd8"/>
-    <p:sldId xmlns:r="http://schemas.openxmlformats.org/officeDocument/2006/relationships" id="263" r:id="R92e6d0580f4d4b71"/>
-    <p:sldId xmlns:r="http://schemas.openxmlformats.org/officeDocument/2006/relationships" id="264" r:id="R74cedbfa1c294bc1"/>
+    <p:sldId xmlns:r="http://schemas.openxmlformats.org/officeDocument/2006/relationships" id="256" r:id="Rb8f1a4295bbd4f26"/>
+    <p:sldId xmlns:r="http://schemas.openxmlformats.org/officeDocument/2006/relationships" id="257" r:id="R93d130fb76644fc2"/>
+    <p:sldId xmlns:r="http://schemas.openxmlformats.org/officeDocument/2006/relationships" id="258" r:id="R202a4c79e709472c"/>
+    <p:sldId xmlns:r="http://schemas.openxmlformats.org/officeDocument/2006/relationships" id="259" r:id="R9cd8346605ab442a"/>
+    <p:sldId xmlns:r="http://schemas.openxmlformats.org/officeDocument/2006/relationships" id="260" r:id="R6eef603a94634338"/>
+    <p:sldId xmlns:r="http://schemas.openxmlformats.org/officeDocument/2006/relationships" id="261" r:id="Rd178682eff924f69"/>
+    <p:sldId xmlns:r="http://schemas.openxmlformats.org/officeDocument/2006/relationships" id="262" r:id="R7cd4e65357c049bd"/>
+    <p:sldId xmlns:r="http://schemas.openxmlformats.org/officeDocument/2006/relationships" id="263" r:id="R44609e23a46b4da6"/>
+    <p:sldId xmlns:r="http://schemas.openxmlformats.org/officeDocument/2006/relationships" id="264" r:id="R5012543461934058"/>
   </p:sldIdLst>
   <p:sldSz cx="9144000" cy="5143500"/>
   <p:notesSz cx="6858000" cy="9144000"/>
@@ -520,7 +520,7 @@
           <a:lstStyle xmlns:a="http://schemas.openxmlformats.org/drawingml/2006/main"/>
           <a:p xmlns:a="http://schemas.openxmlformats.org/drawingml/2006/main">
             <a:r>
-              <a:t>中間発表型表紙の静止レイアウト見本。背景は素材枠で、動画も静止ポスターも未提供・未同梱。利用者の動画を指定された加工・無音・自動再生・ループ・次ページでの停止条件で埋め込む。対象アプリでの再生検証は別工程。本文のデザインはFIT型表紙を選んでも同じ。</a:t>
+              <a:t>表紙タイプBの静止レイアウト見本。背景は素材枠で、動画も静止ポスターも未提供・未同梱。利用者の動画を指定された加工・無音・自動再生・ループ・次ページでの停止条件で埋め込む。対象アプリでの再生検証は別工程。本文のデザインは表紙タイプAを選んでも同じ。</a:t>
             </a:r>
           </a:p>
         </p:txBody>
@@ -1103,7 +1103,7 @@
   </p:cSld>
   <p:clrMap bg1="lt1" tx1="dk1" bg2="lt2" tx2="dk2" accent1="accent1" accent2="accent2" accent3="accent3" accent4="accent4" accent5="accent5" accent6="accent6" hlink="hlink" folHlink="folHlink"/>
   <p:sldLayoutIdLst>
-    <p:sldLayoutId xmlns:r="http://schemas.openxmlformats.org/officeDocument/2006/relationships" id="2147483649" r:id="R0a5eeb090a844a8f"/>
+    <p:sldLayoutId xmlns:r="http://schemas.openxmlformats.org/officeDocument/2006/relationships" id="2147483649" r:id="Ra82ed56288874f43"/>
   </p:sldLayoutIdLst>
   <p:txStyles>
     <p:titleStyle>
@@ -2106,7 +2106,7 @@
           <p:cNvPr id="11" name="footer-line">
             <a:extLst xmlns:a="http://schemas.openxmlformats.org/drawingml/2006/main">
               <a:ext uri="{FF2B5EF4-FFF2-40B4-BE49-F238E27FC236}">
-                <a16:creationId xmlns:a16="http://schemas.microsoft.com/office/drawing/2014/main" id="{447434D0-0A16-4AE6-A306-9318B1D8D5A9}"/>
+                <a16:creationId xmlns:a16="http://schemas.microsoft.com/office/drawing/2014/main" id="{2C4FF54D-94B1-4F54-9B73-C0B220707A18}"/>
               </a:ext>
             </a:extLst>
           </p:cNvPr>
@@ -2141,7 +2141,7 @@
           <p:nvPr/>
         </p:nvPicPr>
         <p:blipFill>
-          <a:blip xmlns:r="http://schemas.openxmlformats.org/officeDocument/2006/relationships" xmlns:a="http://schemas.openxmlformats.org/drawingml/2006/main" r:embed="R3934e8ef289f42c0"/>
+          <a:blip xmlns:r="http://schemas.openxmlformats.org/officeDocument/2006/relationships" xmlns:a="http://schemas.openxmlformats.org/drawingml/2006/main" r:embed="R7b52766541214025"/>
           <a:stretch xmlns:a="http://schemas.openxmlformats.org/drawingml/2006/main"/>
         </p:blipFill>
         <p:spPr>
@@ -2159,7 +2159,7 @@
           <p:cNvPr id="3" name="page">
             <a:extLst xmlns:a="http://schemas.openxmlformats.org/drawingml/2006/main">
               <a:ext uri="{FF2B5EF4-FFF2-40B4-BE49-F238E27FC236}">
-                <a16:creationId xmlns:a16="http://schemas.microsoft.com/office/drawing/2014/main" id="{2E8E3E4B-7AE4-4134-9F95-8CEA951F83CA}"/>
+                <a16:creationId xmlns:a16="http://schemas.microsoft.com/office/drawing/2014/main" id="{F1B593C2-79C1-4B0F-A8CD-4C8898DACC46}"/>
               </a:ext>
             </a:extLst>
           </p:cNvPr>
@@ -2217,7 +2217,7 @@
           <p:cNvPr id="4" name="fictional-disclosure">
             <a:extLst xmlns:a="http://schemas.openxmlformats.org/drawingml/2006/main">
               <a:ext uri="{FF2B5EF4-FFF2-40B4-BE49-F238E27FC236}">
-                <a16:creationId xmlns:a16="http://schemas.microsoft.com/office/drawing/2014/main" id="{5ACED371-0E27-4FB4-8B98-295AAFD8FBC1}"/>
+                <a16:creationId xmlns:a16="http://schemas.microsoft.com/office/drawing/2014/main" id="{8BF51813-066F-466F-94D1-86E50B3B22B5}"/>
               </a:ext>
             </a:extLst>
           </p:cNvPr>
@@ -2275,7 +2275,7 @@
           <p:cNvPr id="5" name="venue">
             <a:extLst xmlns:a="http://schemas.openxmlformats.org/drawingml/2006/main">
               <a:ext uri="{FF2B5EF4-FFF2-40B4-BE49-F238E27FC236}">
-                <a16:creationId xmlns:a16="http://schemas.microsoft.com/office/drawing/2014/main" id="{5503702E-2B66-4979-A8C2-331BBB2A4247}"/>
+                <a16:creationId xmlns:a16="http://schemas.microsoft.com/office/drawing/2014/main" id="{5817D363-8278-4271-8565-F19F013C7C31}"/>
               </a:ext>
             </a:extLst>
           </p:cNvPr>
@@ -2333,7 +2333,7 @@
           <p:cNvPr id="6" name="topic">
             <a:extLst xmlns:a="http://schemas.openxmlformats.org/drawingml/2006/main">
               <a:ext uri="{FF2B5EF4-FFF2-40B4-BE49-F238E27FC236}">
-                <a16:creationId xmlns:a16="http://schemas.microsoft.com/office/drawing/2014/main" id="{C773E99D-9C03-4553-BA3D-4CA7A42226F4}"/>
+                <a16:creationId xmlns:a16="http://schemas.microsoft.com/office/drawing/2014/main" id="{82806F90-78A4-4BCE-A964-07C9569909FB}"/>
               </a:ext>
             </a:extLst>
           </p:cNvPr>
@@ -2416,7 +2416,7 @@
           <p:cNvPr id="7" name="affiliation">
             <a:extLst xmlns:a="http://schemas.openxmlformats.org/drawingml/2006/main">
               <a:ext uri="{FF2B5EF4-FFF2-40B4-BE49-F238E27FC236}">
-                <a16:creationId xmlns:a16="http://schemas.microsoft.com/office/drawing/2014/main" id="{23FA7F74-CCA0-4150-96B8-EE20A375FD5C}"/>
+                <a16:creationId xmlns:a16="http://schemas.microsoft.com/office/drawing/2014/main" id="{62A47AF2-A2CD-4C2E-8BCD-F41C52874567}"/>
               </a:ext>
             </a:extLst>
           </p:cNvPr>
@@ -2476,7 +2476,7 @@
           <p:cNvPr id="8" name="author">
             <a:extLst xmlns:a="http://schemas.openxmlformats.org/drawingml/2006/main">
               <a:ext uri="{FF2B5EF4-FFF2-40B4-BE49-F238E27FC236}">
-                <a16:creationId xmlns:a16="http://schemas.microsoft.com/office/drawing/2014/main" id="{6EA0A61A-A57F-421E-A342-C45BE5955F68}"/>
+                <a16:creationId xmlns:a16="http://schemas.microsoft.com/office/drawing/2014/main" id="{B067A746-2DC7-4AEA-AB1F-D9FD1D5B3318}"/>
               </a:ext>
             </a:extLst>
           </p:cNvPr>
@@ -2536,7 +2536,7 @@
           <p:cNvPr id="9" name="research-photo-slot">
             <a:extLst xmlns:a="http://schemas.openxmlformats.org/drawingml/2006/main">
               <a:ext uri="{FF2B5EF4-FFF2-40B4-BE49-F238E27FC236}">
-                <a16:creationId xmlns:a16="http://schemas.microsoft.com/office/drawing/2014/main" id="{666C34DE-26AC-4522-B99E-6072FB806CB0}"/>
+                <a16:creationId xmlns:a16="http://schemas.microsoft.com/office/drawing/2014/main" id="{8F48CFB9-D28B-48BB-B4A1-2647B063D08E}"/>
               </a:ext>
             </a:extLst>
           </p:cNvPr>
@@ -2569,7 +2569,7 @@
           <p:cNvPr id="10" name="photo-slot-label">
             <a:extLst xmlns:a="http://schemas.openxmlformats.org/drawingml/2006/main">
               <a:ext uri="{FF2B5EF4-FFF2-40B4-BE49-F238E27FC236}">
-                <a16:creationId xmlns:a16="http://schemas.microsoft.com/office/drawing/2014/main" id="{888B936E-6798-420F-97D5-0BC422F5E839}"/>
+                <a16:creationId xmlns:a16="http://schemas.microsoft.com/office/drawing/2014/main" id="{59F961B4-23A4-485B-8DE2-0F7436B2C03A}"/>
               </a:ext>
             </a:extLst>
           </p:cNvPr>
@@ -2648,7 +2648,7 @@
     </p:spTree>
     <p:extLst>
       <p:ext uri="{BB962C8B-B14F-4D97-AF65-F5344CB8AC3E}">
-        <p14:creationId xmlns:p14="http://schemas.microsoft.com/office/powerpoint/2010/main" val="1550800608"/>
+        <p14:creationId xmlns:p14="http://schemas.microsoft.com/office/powerpoint/2010/main" val="1970042511"/>
       </p:ext>
     </p:extLst>
   </p:cSld>
@@ -2679,7 +2679,7 @@
           <p:cNvPr id="8" name="venue">
             <a:extLst xmlns:a="http://schemas.openxmlformats.org/drawingml/2006/main">
               <a:ext uri="{FF2B5EF4-FFF2-40B4-BE49-F238E27FC236}">
-                <a16:creationId xmlns:a16="http://schemas.microsoft.com/office/drawing/2014/main" id="{4C6719A6-1271-4569-B6C6-EE9DC3B7AB54}"/>
+                <a16:creationId xmlns:a16="http://schemas.microsoft.com/office/drawing/2014/main" id="{6F61255B-13AE-4E1F-8C64-05EBD216D657}"/>
               </a:ext>
             </a:extLst>
           </p:cNvPr>
@@ -2737,7 +2737,7 @@
           <p:cNvPr id="2" name="topic">
             <a:extLst xmlns:a="http://schemas.openxmlformats.org/drawingml/2006/main">
               <a:ext uri="{FF2B5EF4-FFF2-40B4-BE49-F238E27FC236}">
-                <a16:creationId xmlns:a16="http://schemas.microsoft.com/office/drawing/2014/main" id="{DFC5A7EC-187B-4BDC-97FD-BC06B4E22777}"/>
+                <a16:creationId xmlns:a16="http://schemas.microsoft.com/office/drawing/2014/main" id="{D250210E-28C2-4841-BA6A-609F90244A82}"/>
               </a:ext>
             </a:extLst>
           </p:cNvPr>
@@ -2818,7 +2818,7 @@
           <p:cNvPr id="3" name="affiliation">
             <a:extLst xmlns:a="http://schemas.openxmlformats.org/drawingml/2006/main">
               <a:ext uri="{FF2B5EF4-FFF2-40B4-BE49-F238E27FC236}">
-                <a16:creationId xmlns:a16="http://schemas.microsoft.com/office/drawing/2014/main" id="{E384D41C-E821-43E4-88B0-264E6F9FD803}"/>
+                <a16:creationId xmlns:a16="http://schemas.microsoft.com/office/drawing/2014/main" id="{13DF0CF5-68B8-49C7-8DB1-B913D2497370}"/>
               </a:ext>
             </a:extLst>
           </p:cNvPr>
@@ -2876,7 +2876,7 @@
           <p:cNvPr id="4" name="author">
             <a:extLst xmlns:a="http://schemas.openxmlformats.org/drawingml/2006/main">
               <a:ext uri="{FF2B5EF4-FFF2-40B4-BE49-F238E27FC236}">
-                <a16:creationId xmlns:a16="http://schemas.microsoft.com/office/drawing/2014/main" id="{A2F63464-6598-48DD-8352-6925B0D8121E}"/>
+                <a16:creationId xmlns:a16="http://schemas.microsoft.com/office/drawing/2014/main" id="{F2838BA7-158E-490D-8E44-88DCAB22C970}"/>
               </a:ext>
             </a:extLst>
           </p:cNvPr>
@@ -2934,7 +2934,7 @@
           <p:cNvPr id="5" name="media-placeholder">
             <a:extLst xmlns:a="http://schemas.openxmlformats.org/drawingml/2006/main">
               <a:ext uri="{FF2B5EF4-FFF2-40B4-BE49-F238E27FC236}">
-                <a16:creationId xmlns:a16="http://schemas.microsoft.com/office/drawing/2014/main" id="{EDE6825C-DA90-4467-8D3C-0FCB0CE10A92}"/>
+                <a16:creationId xmlns:a16="http://schemas.microsoft.com/office/drawing/2014/main" id="{A4DDFF30-297E-432A-9162-80937404D99A}"/>
               </a:ext>
             </a:extLst>
           </p:cNvPr>
@@ -2992,7 +2992,7 @@
           <p:cNvPr id="6" name="fictional-disclosure">
             <a:extLst xmlns:a="http://schemas.openxmlformats.org/drawingml/2006/main">
               <a:ext uri="{FF2B5EF4-FFF2-40B4-BE49-F238E27FC236}">
-                <a16:creationId xmlns:a16="http://schemas.microsoft.com/office/drawing/2014/main" id="{16DAFF6A-A321-4223-A673-1D158C9D84FF}"/>
+                <a16:creationId xmlns:a16="http://schemas.microsoft.com/office/drawing/2014/main" id="{36F3B395-A868-43AF-A4F9-636A332A115D}"/>
               </a:ext>
             </a:extLst>
           </p:cNvPr>
@@ -3050,7 +3050,7 @@
           <p:cNvPr id="7" name="page">
             <a:extLst xmlns:a="http://schemas.openxmlformats.org/drawingml/2006/main">
               <a:ext uri="{FF2B5EF4-FFF2-40B4-BE49-F238E27FC236}">
-                <a16:creationId xmlns:a16="http://schemas.microsoft.com/office/drawing/2014/main" id="{1FF7DC57-CEF9-430C-BA46-72BEF788F16C}"/>
+                <a16:creationId xmlns:a16="http://schemas.microsoft.com/office/drawing/2014/main" id="{F441D28E-6C96-4291-9211-38729D122575}"/>
               </a:ext>
             </a:extLst>
           </p:cNvPr>
@@ -3106,7 +3106,7 @@
     </p:spTree>
     <p:extLst>
       <p:ext uri="{BB962C8B-B14F-4D97-AF65-F5344CB8AC3E}">
-        <p14:creationId xmlns:p14="http://schemas.microsoft.com/office/powerpoint/2010/main" val="1453211732"/>
+        <p14:creationId xmlns:p14="http://schemas.microsoft.com/office/powerpoint/2010/main" val="803959514"/>
       </p:ext>
     </p:extLst>
   </p:cSld>
@@ -3137,7 +3137,7 @@
           <p:cNvPr id="24" name="footer-line">
             <a:extLst xmlns:a="http://schemas.openxmlformats.org/drawingml/2006/main">
               <a:ext uri="{FF2B5EF4-FFF2-40B4-BE49-F238E27FC236}">
-                <a16:creationId xmlns:a16="http://schemas.microsoft.com/office/drawing/2014/main" id="{CD8DCBF0-DCB5-442F-92BB-E721B18E57D5}"/>
+                <a16:creationId xmlns:a16="http://schemas.microsoft.com/office/drawing/2014/main" id="{0CF76A38-79BF-42D0-A8FF-9B56CD7947A6}"/>
               </a:ext>
             </a:extLst>
           </p:cNvPr>
@@ -3172,7 +3172,7 @@
           <p:nvPr/>
         </p:nvPicPr>
         <p:blipFill>
-          <a:blip xmlns:r="http://schemas.openxmlformats.org/officeDocument/2006/relationships" xmlns:a="http://schemas.openxmlformats.org/drawingml/2006/main" r:embed="Rfc32e06682b64dba"/>
+          <a:blip xmlns:r="http://schemas.openxmlformats.org/officeDocument/2006/relationships" xmlns:a="http://schemas.openxmlformats.org/drawingml/2006/main" r:embed="R77ae94c99d21455d"/>
           <a:stretch xmlns:a="http://schemas.openxmlformats.org/drawingml/2006/main"/>
         </p:blipFill>
         <p:spPr>
@@ -3190,7 +3190,7 @@
           <p:cNvPr id="3" name="page">
             <a:extLst xmlns:a="http://schemas.openxmlformats.org/drawingml/2006/main">
               <a:ext uri="{FF2B5EF4-FFF2-40B4-BE49-F238E27FC236}">
-                <a16:creationId xmlns:a16="http://schemas.microsoft.com/office/drawing/2014/main" id="{925ECE44-CA86-4CB9-813A-A4814E8443F3}"/>
+                <a16:creationId xmlns:a16="http://schemas.microsoft.com/office/drawing/2014/main" id="{1747D922-61D4-437F-81F7-DD753A466ECF}"/>
               </a:ext>
             </a:extLst>
           </p:cNvPr>
@@ -3248,7 +3248,7 @@
           <p:cNvPr id="4" name="fictional-disclosure">
             <a:extLst xmlns:a="http://schemas.openxmlformats.org/drawingml/2006/main">
               <a:ext uri="{FF2B5EF4-FFF2-40B4-BE49-F238E27FC236}">
-                <a16:creationId xmlns:a16="http://schemas.microsoft.com/office/drawing/2014/main" id="{5A169156-55AC-404A-B66C-8ECCA487A897}"/>
+                <a16:creationId xmlns:a16="http://schemas.microsoft.com/office/drawing/2014/main" id="{23A6E96B-F1EA-4D48-9039-C5CCA2A23DF1}"/>
               </a:ext>
             </a:extLst>
           </p:cNvPr>
@@ -3306,7 +3306,7 @@
           <p:cNvPr id="5" name="running-chapter-3">
             <a:extLst xmlns:a="http://schemas.openxmlformats.org/drawingml/2006/main">
               <a:ext uri="{FF2B5EF4-FFF2-40B4-BE49-F238E27FC236}">
-                <a16:creationId xmlns:a16="http://schemas.microsoft.com/office/drawing/2014/main" id="{B6797448-1DEE-4EB3-B191-90C49EDA03D0}"/>
+                <a16:creationId xmlns:a16="http://schemas.microsoft.com/office/drawing/2014/main" id="{E875A1FD-B107-428B-8A0A-DFDD46978CBD}"/>
               </a:ext>
             </a:extLst>
           </p:cNvPr>
@@ -3364,7 +3364,7 @@
           <p:cNvPr id="6" name="running-title-3">
             <a:extLst xmlns:a="http://schemas.openxmlformats.org/drawingml/2006/main">
               <a:ext uri="{FF2B5EF4-FFF2-40B4-BE49-F238E27FC236}">
-                <a16:creationId xmlns:a16="http://schemas.microsoft.com/office/drawing/2014/main" id="{28BC48D8-73E4-4DAA-8580-D8BC5635A18A}"/>
+                <a16:creationId xmlns:a16="http://schemas.microsoft.com/office/drawing/2014/main" id="{6D8C23E4-D6B4-4E05-835C-A8FF3374C09E}"/>
               </a:ext>
             </a:extLst>
           </p:cNvPr>
@@ -3422,7 +3422,7 @@
           <p:cNvPr id="7" name="title">
             <a:extLst xmlns:a="http://schemas.openxmlformats.org/drawingml/2006/main">
               <a:ext uri="{FF2B5EF4-FFF2-40B4-BE49-F238E27FC236}">
-                <a16:creationId xmlns:a16="http://schemas.microsoft.com/office/drawing/2014/main" id="{322D3E7A-2D8D-499C-B592-E76DA4BC98B4}"/>
+                <a16:creationId xmlns:a16="http://schemas.microsoft.com/office/drawing/2014/main" id="{EBFE022A-F771-4D2C-89DB-2C0EA8638568}"/>
               </a:ext>
             </a:extLst>
           </p:cNvPr>
@@ -3480,7 +3480,7 @@
           <p:cNvPr id="8" name="message">
             <a:extLst xmlns:a="http://schemas.openxmlformats.org/drawingml/2006/main">
               <a:ext uri="{FF2B5EF4-FFF2-40B4-BE49-F238E27FC236}">
-                <a16:creationId xmlns:a16="http://schemas.microsoft.com/office/drawing/2014/main" id="{179B518C-D659-42FD-BC5B-F132218A76E0}"/>
+                <a16:creationId xmlns:a16="http://schemas.microsoft.com/office/drawing/2014/main" id="{00C5FBAB-EB6E-4EB4-838E-5F9546842467}"/>
               </a:ext>
             </a:extLst>
           </p:cNvPr>
@@ -3538,7 +3538,7 @@
           <p:cNvPr id="9" name="toc-label-0">
             <a:extLst xmlns:a="http://schemas.openxmlformats.org/drawingml/2006/main">
               <a:ext uri="{FF2B5EF4-FFF2-40B4-BE49-F238E27FC236}">
-                <a16:creationId xmlns:a16="http://schemas.microsoft.com/office/drawing/2014/main" id="{5EF5D9AA-C55C-420D-BB27-F9AF15E060C7}"/>
+                <a16:creationId xmlns:a16="http://schemas.microsoft.com/office/drawing/2014/main" id="{07C12E99-4276-4B0D-A172-0DE29F3B5BD6}"/>
               </a:ext>
             </a:extLst>
           </p:cNvPr>
@@ -3596,7 +3596,7 @@
           <p:cNvPr id="10" name="toc-image-slot-0">
             <a:extLst xmlns:a="http://schemas.openxmlformats.org/drawingml/2006/main">
               <a:ext uri="{FF2B5EF4-FFF2-40B4-BE49-F238E27FC236}">
-                <a16:creationId xmlns:a16="http://schemas.microsoft.com/office/drawing/2014/main" id="{87200B74-5F71-4235-B376-3D0561B75393}"/>
+                <a16:creationId xmlns:a16="http://schemas.microsoft.com/office/drawing/2014/main" id="{A781293C-0CB9-4C62-984B-C88132DEAA84}"/>
               </a:ext>
             </a:extLst>
           </p:cNvPr>
@@ -3629,7 +3629,7 @@
           <p:cNvPr id="11" name="toc-image-label-0">
             <a:extLst xmlns:a="http://schemas.openxmlformats.org/drawingml/2006/main">
               <a:ext uri="{FF2B5EF4-FFF2-40B4-BE49-F238E27FC236}">
-                <a16:creationId xmlns:a16="http://schemas.microsoft.com/office/drawing/2014/main" id="{7D8FFD9C-32A8-4E50-B7E6-9CC7D46E4406}"/>
+                <a16:creationId xmlns:a16="http://schemas.microsoft.com/office/drawing/2014/main" id="{93CCD2E4-2966-447A-B575-5F8742A651BC}"/>
               </a:ext>
             </a:extLst>
           </p:cNvPr>
@@ -3687,7 +3687,7 @@
           <p:cNvPr id="12" name="toc-label-1">
             <a:extLst xmlns:a="http://schemas.openxmlformats.org/drawingml/2006/main">
               <a:ext uri="{FF2B5EF4-FFF2-40B4-BE49-F238E27FC236}">
-                <a16:creationId xmlns:a16="http://schemas.microsoft.com/office/drawing/2014/main" id="{E424823D-E41D-4A0C-9FE4-54C306FE16B7}"/>
+                <a16:creationId xmlns:a16="http://schemas.microsoft.com/office/drawing/2014/main" id="{C3A4044B-41D4-4E00-89A0-326448FC89F1}"/>
               </a:ext>
             </a:extLst>
           </p:cNvPr>
@@ -3745,7 +3745,7 @@
           <p:cNvPr id="13" name="toc-image-slot-1">
             <a:extLst xmlns:a="http://schemas.openxmlformats.org/drawingml/2006/main">
               <a:ext uri="{FF2B5EF4-FFF2-40B4-BE49-F238E27FC236}">
-                <a16:creationId xmlns:a16="http://schemas.microsoft.com/office/drawing/2014/main" id="{98A2516F-21A8-4C40-9753-C89041410F75}"/>
+                <a16:creationId xmlns:a16="http://schemas.microsoft.com/office/drawing/2014/main" id="{7F320DBB-7BA5-4BA3-8B0D-9321E1913A20}"/>
               </a:ext>
             </a:extLst>
           </p:cNvPr>
@@ -3778,7 +3778,7 @@
           <p:cNvPr id="14" name="toc-image-label-1">
             <a:extLst xmlns:a="http://schemas.openxmlformats.org/drawingml/2006/main">
               <a:ext uri="{FF2B5EF4-FFF2-40B4-BE49-F238E27FC236}">
-                <a16:creationId xmlns:a16="http://schemas.microsoft.com/office/drawing/2014/main" id="{B2466703-1AD5-4EE8-A9A1-690CCBD01FDB}"/>
+                <a16:creationId xmlns:a16="http://schemas.microsoft.com/office/drawing/2014/main" id="{4E0FDF55-C2F4-40DF-B831-564A7B2896E7}"/>
               </a:ext>
             </a:extLst>
           </p:cNvPr>
@@ -3836,7 +3836,7 @@
           <p:cNvPr id="15" name="toc-label-2">
             <a:extLst xmlns:a="http://schemas.openxmlformats.org/drawingml/2006/main">
               <a:ext uri="{FF2B5EF4-FFF2-40B4-BE49-F238E27FC236}">
-                <a16:creationId xmlns:a16="http://schemas.microsoft.com/office/drawing/2014/main" id="{80F3C4C3-B764-4F4B-8BCC-80CD9C0E8DDF}"/>
+                <a16:creationId xmlns:a16="http://schemas.microsoft.com/office/drawing/2014/main" id="{206A3567-3112-4E29-A18F-CE092BFF4E83}"/>
               </a:ext>
             </a:extLst>
           </p:cNvPr>
@@ -3894,7 +3894,7 @@
           <p:cNvPr id="16" name="toc-image-slot-2">
             <a:extLst xmlns:a="http://schemas.openxmlformats.org/drawingml/2006/main">
               <a:ext uri="{FF2B5EF4-FFF2-40B4-BE49-F238E27FC236}">
-                <a16:creationId xmlns:a16="http://schemas.microsoft.com/office/drawing/2014/main" id="{96F88C99-BC84-44D7-B690-CD45FDCA766E}"/>
+                <a16:creationId xmlns:a16="http://schemas.microsoft.com/office/drawing/2014/main" id="{84857111-E1BE-4800-A260-969C77139D3F}"/>
               </a:ext>
             </a:extLst>
           </p:cNvPr>
@@ -3927,7 +3927,7 @@
           <p:cNvPr id="17" name="toc-image-label-2">
             <a:extLst xmlns:a="http://schemas.openxmlformats.org/drawingml/2006/main">
               <a:ext uri="{FF2B5EF4-FFF2-40B4-BE49-F238E27FC236}">
-                <a16:creationId xmlns:a16="http://schemas.microsoft.com/office/drawing/2014/main" id="{2EF0AC1C-3CF4-4DE7-99F9-98724891552B}"/>
+                <a16:creationId xmlns:a16="http://schemas.microsoft.com/office/drawing/2014/main" id="{2EACE051-71A4-4F03-8751-B84DDE1F26BD}"/>
               </a:ext>
             </a:extLst>
           </p:cNvPr>
@@ -3985,7 +3985,7 @@
           <p:cNvPr id="18" name="toc-label-3">
             <a:extLst xmlns:a="http://schemas.openxmlformats.org/drawingml/2006/main">
               <a:ext uri="{FF2B5EF4-FFF2-40B4-BE49-F238E27FC236}">
-                <a16:creationId xmlns:a16="http://schemas.microsoft.com/office/drawing/2014/main" id="{17ED5554-B8A1-4B3D-BBC1-44D595AB06D6}"/>
+                <a16:creationId xmlns:a16="http://schemas.microsoft.com/office/drawing/2014/main" id="{9FC8B1C0-0CFE-40D0-A531-7E92E51DF413}"/>
               </a:ext>
             </a:extLst>
           </p:cNvPr>
@@ -4043,7 +4043,7 @@
           <p:cNvPr id="19" name="toc-image-slot-3">
             <a:extLst xmlns:a="http://schemas.openxmlformats.org/drawingml/2006/main">
               <a:ext uri="{FF2B5EF4-FFF2-40B4-BE49-F238E27FC236}">
-                <a16:creationId xmlns:a16="http://schemas.microsoft.com/office/drawing/2014/main" id="{24590022-86B2-4396-BCD4-26C06C718AE4}"/>
+                <a16:creationId xmlns:a16="http://schemas.microsoft.com/office/drawing/2014/main" id="{C69BBE06-3181-43CE-9805-EC7D141C6AA3}"/>
               </a:ext>
             </a:extLst>
           </p:cNvPr>
@@ -4076,7 +4076,7 @@
           <p:cNvPr id="20" name="toc-image-label-3">
             <a:extLst xmlns:a="http://schemas.openxmlformats.org/drawingml/2006/main">
               <a:ext uri="{FF2B5EF4-FFF2-40B4-BE49-F238E27FC236}">
-                <a16:creationId xmlns:a16="http://schemas.microsoft.com/office/drawing/2014/main" id="{23CF8BFE-41AC-4A92-9195-37A0E72F1092}"/>
+                <a16:creationId xmlns:a16="http://schemas.microsoft.com/office/drawing/2014/main" id="{461E0A1D-E70F-43F7-AA4E-84184254AED9}"/>
               </a:ext>
             </a:extLst>
           </p:cNvPr>
@@ -4134,7 +4134,7 @@
           <p:cNvPr id="21" name="toc-rule-vertical">
             <a:extLst xmlns:a="http://schemas.openxmlformats.org/drawingml/2006/main">
               <a:ext uri="{FF2B5EF4-FFF2-40B4-BE49-F238E27FC236}">
-                <a16:creationId xmlns:a16="http://schemas.microsoft.com/office/drawing/2014/main" id="{02B31645-70A8-49FD-80CF-CF76822B2C0F}"/>
+                <a16:creationId xmlns:a16="http://schemas.microsoft.com/office/drawing/2014/main" id="{73F8CB40-1A3C-4E04-9738-1F7702AE1238}"/>
               </a:ext>
             </a:extLst>
           </p:cNvPr>
@@ -4165,7 +4165,7 @@
           <p:cNvPr id="22" name="toc-rule-horizontal">
             <a:extLst xmlns:a="http://schemas.openxmlformats.org/drawingml/2006/main">
               <a:ext uri="{FF2B5EF4-FFF2-40B4-BE49-F238E27FC236}">
-                <a16:creationId xmlns:a16="http://schemas.microsoft.com/office/drawing/2014/main" id="{0791F0E3-5EDE-4A04-A874-2BF7E1CE24DE}"/>
+                <a16:creationId xmlns:a16="http://schemas.microsoft.com/office/drawing/2014/main" id="{F140F0E7-4BDD-4F0C-BD0A-6F3B7003CC52}"/>
               </a:ext>
             </a:extLst>
           </p:cNvPr>
@@ -4196,7 +4196,7 @@
           <p:cNvPr id="23" name="slot-disclosure">
             <a:extLst xmlns:a="http://schemas.openxmlformats.org/drawingml/2006/main">
               <a:ext uri="{FF2B5EF4-FFF2-40B4-BE49-F238E27FC236}">
-                <a16:creationId xmlns:a16="http://schemas.microsoft.com/office/drawing/2014/main" id="{4CAA2F64-3CE9-420F-9A52-9119C52D7BD4}"/>
+                <a16:creationId xmlns:a16="http://schemas.microsoft.com/office/drawing/2014/main" id="{838F11B6-FAFF-4DB6-ADF7-5B597CADA958}"/>
               </a:ext>
             </a:extLst>
           </p:cNvPr>
@@ -4252,7 +4252,7 @@
     </p:spTree>
     <p:extLst>
       <p:ext uri="{BB962C8B-B14F-4D97-AF65-F5344CB8AC3E}">
-        <p14:creationId xmlns:p14="http://schemas.microsoft.com/office/powerpoint/2010/main" val="1538059938"/>
+        <p14:creationId xmlns:p14="http://schemas.microsoft.com/office/powerpoint/2010/main" val="1982297688"/>
       </p:ext>
     </p:extLst>
   </p:cSld>
@@ -4287,7 +4287,7 @@
           <p:nvPr/>
         </p:nvPicPr>
         <p:blipFill>
-          <a:blip xmlns:r="http://schemas.openxmlformats.org/officeDocument/2006/relationships" xmlns:a="http://schemas.openxmlformats.org/drawingml/2006/main" r:embed="R7ae9e244246a427a"/>
+          <a:blip xmlns:r="http://schemas.openxmlformats.org/officeDocument/2006/relationships" xmlns:a="http://schemas.openxmlformats.org/drawingml/2006/main" r:embed="R959b4a5f4ca7411d"/>
           <a:stretch xmlns:a="http://schemas.openxmlformats.org/drawingml/2006/main"/>
         </p:blipFill>
         <p:spPr>
@@ -4305,7 +4305,7 @@
           <p:cNvPr id="2" name="page">
             <a:extLst xmlns:a="http://schemas.openxmlformats.org/drawingml/2006/main">
               <a:ext uri="{FF2B5EF4-FFF2-40B4-BE49-F238E27FC236}">
-                <a16:creationId xmlns:a16="http://schemas.microsoft.com/office/drawing/2014/main" id="{CE9FED70-B401-4D6B-9AB7-37E3D8636649}"/>
+                <a16:creationId xmlns:a16="http://schemas.microsoft.com/office/drawing/2014/main" id="{8507D0D6-F18E-4374-AFFA-9079DBAE6F39}"/>
               </a:ext>
             </a:extLst>
           </p:cNvPr>
@@ -4363,7 +4363,7 @@
           <p:cNvPr id="3" name="fictional-disclosure">
             <a:extLst xmlns:a="http://schemas.openxmlformats.org/drawingml/2006/main">
               <a:ext uri="{FF2B5EF4-FFF2-40B4-BE49-F238E27FC236}">
-                <a16:creationId xmlns:a16="http://schemas.microsoft.com/office/drawing/2014/main" id="{518AA6D0-C7D9-478A-81EC-982C71A0B346}"/>
+                <a16:creationId xmlns:a16="http://schemas.microsoft.com/office/drawing/2014/main" id="{6FEE40ED-525E-48EC-9188-31A9B3595DE2}"/>
               </a:ext>
             </a:extLst>
           </p:cNvPr>
@@ -4421,7 +4421,7 @@
           <p:cNvPr id="4" name="running-chapter-4">
             <a:extLst xmlns:a="http://schemas.openxmlformats.org/drawingml/2006/main">
               <a:ext uri="{FF2B5EF4-FFF2-40B4-BE49-F238E27FC236}">
-                <a16:creationId xmlns:a16="http://schemas.microsoft.com/office/drawing/2014/main" id="{F084B203-9F1E-4DBC-88F9-781FE5238555}"/>
+                <a16:creationId xmlns:a16="http://schemas.microsoft.com/office/drawing/2014/main" id="{8F85C86D-9CA4-4D2B-945F-CC802B623590}"/>
               </a:ext>
             </a:extLst>
           </p:cNvPr>
@@ -4479,7 +4479,7 @@
           <p:cNvPr id="5" name="running-title-4">
             <a:extLst xmlns:a="http://schemas.openxmlformats.org/drawingml/2006/main">
               <a:ext uri="{FF2B5EF4-FFF2-40B4-BE49-F238E27FC236}">
-                <a16:creationId xmlns:a16="http://schemas.microsoft.com/office/drawing/2014/main" id="{8819AECB-9B4F-4EC4-B090-5F71B8A48724}"/>
+                <a16:creationId xmlns:a16="http://schemas.microsoft.com/office/drawing/2014/main" id="{CE125A52-7FE6-4E41-81CF-67117D6DE1A0}"/>
               </a:ext>
             </a:extLst>
           </p:cNvPr>
@@ -4537,7 +4537,7 @@
           <p:cNvPr id="6" name="upper-chapter-band">
             <a:extLst xmlns:a="http://schemas.openxmlformats.org/drawingml/2006/main">
               <a:ext uri="{FF2B5EF4-FFF2-40B4-BE49-F238E27FC236}">
-                <a16:creationId xmlns:a16="http://schemas.microsoft.com/office/drawing/2014/main" id="{5FA7E7E2-D809-423D-BC3C-764CEEAE7E0A}"/>
+                <a16:creationId xmlns:a16="http://schemas.microsoft.com/office/drawing/2014/main" id="{BBA8F454-D7EF-424B-95B2-CFCAF362A780}"/>
               </a:ext>
             </a:extLst>
           </p:cNvPr>
@@ -4568,7 +4568,7 @@
           <p:cNvPr id="7" name="chapter">
             <a:extLst xmlns:a="http://schemas.openxmlformats.org/drawingml/2006/main">
               <a:ext uri="{FF2B5EF4-FFF2-40B4-BE49-F238E27FC236}">
-                <a16:creationId xmlns:a16="http://schemas.microsoft.com/office/drawing/2014/main" id="{B85FD012-92C3-45E8-B96C-6526D0281647}"/>
+                <a16:creationId xmlns:a16="http://schemas.microsoft.com/office/drawing/2014/main" id="{205A372C-4581-47AE-9056-3B079D547BC0}"/>
               </a:ext>
             </a:extLst>
           </p:cNvPr>
@@ -4626,7 +4626,7 @@
           <p:cNvPr id="8" name="chapter-guide">
             <a:extLst xmlns:a="http://schemas.openxmlformats.org/drawingml/2006/main">
               <a:ext uri="{FF2B5EF4-FFF2-40B4-BE49-F238E27FC236}">
-                <a16:creationId xmlns:a16="http://schemas.microsoft.com/office/drawing/2014/main" id="{84DA4705-7167-44C0-A820-1FF8C86ECCB2}"/>
+                <a16:creationId xmlns:a16="http://schemas.microsoft.com/office/drawing/2014/main" id="{86386018-D14C-4C43-B274-7AE1314E49BC}"/>
               </a:ext>
             </a:extLst>
           </p:cNvPr>
@@ -4682,7 +4682,7 @@
     </p:spTree>
     <p:extLst>
       <p:ext uri="{BB962C8B-B14F-4D97-AF65-F5344CB8AC3E}">
-        <p14:creationId xmlns:p14="http://schemas.microsoft.com/office/powerpoint/2010/main" val="1206065301"/>
+        <p14:creationId xmlns:p14="http://schemas.microsoft.com/office/powerpoint/2010/main" val="1148291130"/>
       </p:ext>
     </p:extLst>
   </p:cSld>
@@ -4713,7 +4713,7 @@
           <p:cNvPr id="47" name="footer-line">
             <a:extLst xmlns:a="http://schemas.openxmlformats.org/drawingml/2006/main">
               <a:ext uri="{FF2B5EF4-FFF2-40B4-BE49-F238E27FC236}">
-                <a16:creationId xmlns:a16="http://schemas.microsoft.com/office/drawing/2014/main" id="{6CEF54DC-135E-438F-AB25-3E073DB2ED6F}"/>
+                <a16:creationId xmlns:a16="http://schemas.microsoft.com/office/drawing/2014/main" id="{DE5389E3-A5E3-48B2-967C-A4BA90D221EC}"/>
               </a:ext>
             </a:extLst>
           </p:cNvPr>
@@ -4748,7 +4748,7 @@
           <p:nvPr/>
         </p:nvPicPr>
         <p:blipFill>
-          <a:blip xmlns:r="http://schemas.openxmlformats.org/officeDocument/2006/relationships" xmlns:a="http://schemas.openxmlformats.org/drawingml/2006/main" r:embed="R5ecfe005e6c14474"/>
+          <a:blip xmlns:r="http://schemas.openxmlformats.org/officeDocument/2006/relationships" xmlns:a="http://schemas.openxmlformats.org/drawingml/2006/main" r:embed="R4444e54e782e475f"/>
           <a:stretch xmlns:a="http://schemas.openxmlformats.org/drawingml/2006/main"/>
         </p:blipFill>
         <p:spPr>
@@ -4766,7 +4766,7 @@
           <p:cNvPr id="3" name="page">
             <a:extLst xmlns:a="http://schemas.openxmlformats.org/drawingml/2006/main">
               <a:ext uri="{FF2B5EF4-FFF2-40B4-BE49-F238E27FC236}">
-                <a16:creationId xmlns:a16="http://schemas.microsoft.com/office/drawing/2014/main" id="{3AE0E050-A8B5-4625-B3C0-EF1C1252C437}"/>
+                <a16:creationId xmlns:a16="http://schemas.microsoft.com/office/drawing/2014/main" id="{58A3F549-6375-473E-9D05-124F0235699D}"/>
               </a:ext>
             </a:extLst>
           </p:cNvPr>
@@ -4824,7 +4824,7 @@
           <p:cNvPr id="4" name="fictional-disclosure">
             <a:extLst xmlns:a="http://schemas.openxmlformats.org/drawingml/2006/main">
               <a:ext uri="{FF2B5EF4-FFF2-40B4-BE49-F238E27FC236}">
-                <a16:creationId xmlns:a16="http://schemas.microsoft.com/office/drawing/2014/main" id="{6CFDA008-220E-4298-B430-2C60C4780525}"/>
+                <a16:creationId xmlns:a16="http://schemas.microsoft.com/office/drawing/2014/main" id="{A674BBEB-C71D-4D37-ADD9-914AF46D6686}"/>
               </a:ext>
             </a:extLst>
           </p:cNvPr>
@@ -4882,7 +4882,7 @@
           <p:cNvPr id="5" name="running-chapter-5">
             <a:extLst xmlns:a="http://schemas.openxmlformats.org/drawingml/2006/main">
               <a:ext uri="{FF2B5EF4-FFF2-40B4-BE49-F238E27FC236}">
-                <a16:creationId xmlns:a16="http://schemas.microsoft.com/office/drawing/2014/main" id="{FF8D5020-E6CE-4A6B-9BD5-E54B927086D4}"/>
+                <a16:creationId xmlns:a16="http://schemas.microsoft.com/office/drawing/2014/main" id="{81F07456-29FC-45A4-B152-8E92C1FE8CC5}"/>
               </a:ext>
             </a:extLst>
           </p:cNvPr>
@@ -4940,7 +4940,7 @@
           <p:cNvPr id="6" name="running-title-5">
             <a:extLst xmlns:a="http://schemas.openxmlformats.org/drawingml/2006/main">
               <a:ext uri="{FF2B5EF4-FFF2-40B4-BE49-F238E27FC236}">
-                <a16:creationId xmlns:a16="http://schemas.microsoft.com/office/drawing/2014/main" id="{2DFEF992-208B-462D-BB89-8875C51ED107}"/>
+                <a16:creationId xmlns:a16="http://schemas.microsoft.com/office/drawing/2014/main" id="{D39DE680-6021-45D8-9EC2-47F181C1A509}"/>
               </a:ext>
             </a:extLst>
           </p:cNvPr>
@@ -4998,7 +4998,7 @@
           <p:cNvPr id="7" name="title">
             <a:extLst xmlns:a="http://schemas.openxmlformats.org/drawingml/2006/main">
               <a:ext uri="{FF2B5EF4-FFF2-40B4-BE49-F238E27FC236}">
-                <a16:creationId xmlns:a16="http://schemas.microsoft.com/office/drawing/2014/main" id="{339D3992-F4C8-4F54-BBF4-F60019BBEBBF}"/>
+                <a16:creationId xmlns:a16="http://schemas.microsoft.com/office/drawing/2014/main" id="{63EF6B62-6513-4123-A403-A93FAFA6B9AB}"/>
               </a:ext>
             </a:extLst>
           </p:cNvPr>
@@ -5056,7 +5056,7 @@
           <p:cNvPr id="8" name="message">
             <a:extLst xmlns:a="http://schemas.openxmlformats.org/drawingml/2006/main">
               <a:ext uri="{FF2B5EF4-FFF2-40B4-BE49-F238E27FC236}">
-                <a16:creationId xmlns:a16="http://schemas.microsoft.com/office/drawing/2014/main" id="{9EE4A592-CE09-4C6C-9DF2-4C2043B0689C}"/>
+                <a16:creationId xmlns:a16="http://schemas.microsoft.com/office/drawing/2014/main" id="{BB681FC4-63C4-4E06-AEE0-C1C56968D8BB}"/>
               </a:ext>
             </a:extLst>
           </p:cNvPr>
@@ -5114,7 +5114,7 @@
           <p:cNvPr id="9" name="all-label">
             <a:extLst xmlns:a="http://schemas.openxmlformats.org/drawingml/2006/main">
               <a:ext uri="{FF2B5EF4-FFF2-40B4-BE49-F238E27FC236}">
-                <a16:creationId xmlns:a16="http://schemas.microsoft.com/office/drawing/2014/main" id="{38E0CFF2-33A0-45F4-89BD-6B7CEC6CE245}"/>
+                <a16:creationId xmlns:a16="http://schemas.microsoft.com/office/drawing/2014/main" id="{50BB9568-BD1E-4FAB-96AC-4AA02585BEC4}"/>
               </a:ext>
             </a:extLst>
           </p:cNvPr>
@@ -5172,7 +5172,7 @@
           <p:cNvPr id="10" name="kept-label">
             <a:extLst xmlns:a="http://schemas.openxmlformats.org/drawingml/2006/main">
               <a:ext uri="{FF2B5EF4-FFF2-40B4-BE49-F238E27FC236}">
-                <a16:creationId xmlns:a16="http://schemas.microsoft.com/office/drawing/2014/main" id="{CDDF9E05-EDCF-4A65-BD97-33342E78BCC0}"/>
+                <a16:creationId xmlns:a16="http://schemas.microsoft.com/office/drawing/2014/main" id="{5F85A43C-7C26-4DEA-B009-AEFADD487751}"/>
               </a:ext>
             </a:extLst>
           </p:cNvPr>
@@ -5230,7 +5230,7 @@
           <p:cNvPr id="11" name="input-0">
             <a:extLst xmlns:a="http://schemas.openxmlformats.org/drawingml/2006/main">
               <a:ext uri="{FF2B5EF4-FFF2-40B4-BE49-F238E27FC236}">
-                <a16:creationId xmlns:a16="http://schemas.microsoft.com/office/drawing/2014/main" id="{A79EC208-DF17-4D98-BA12-151E8982A28C}"/>
+                <a16:creationId xmlns:a16="http://schemas.microsoft.com/office/drawing/2014/main" id="{3CC4475B-33B9-48BF-A545-83B2C3596EC7}"/>
               </a:ext>
             </a:extLst>
           </p:cNvPr>
@@ -5261,7 +5261,7 @@
           <p:cNvPr id="12" name="minute-0">
             <a:extLst xmlns:a="http://schemas.openxmlformats.org/drawingml/2006/main">
               <a:ext uri="{FF2B5EF4-FFF2-40B4-BE49-F238E27FC236}">
-                <a16:creationId xmlns:a16="http://schemas.microsoft.com/office/drawing/2014/main" id="{E9C5622D-0F67-4FD2-A14B-2F108C575DFE}"/>
+                <a16:creationId xmlns:a16="http://schemas.microsoft.com/office/drawing/2014/main" id="{72F0F5F3-3BBB-4671-A53C-424D154A95A3}"/>
               </a:ext>
             </a:extLst>
           </p:cNvPr>
@@ -5319,7 +5319,7 @@
           <p:cNvPr id="13" name="retained-0">
             <a:extLst xmlns:a="http://schemas.openxmlformats.org/drawingml/2006/main">
               <a:ext uri="{FF2B5EF4-FFF2-40B4-BE49-F238E27FC236}">
-                <a16:creationId xmlns:a16="http://schemas.microsoft.com/office/drawing/2014/main" id="{B02AD77E-955B-4D6D-929B-91EE45B4EFF8}"/>
+                <a16:creationId xmlns:a16="http://schemas.microsoft.com/office/drawing/2014/main" id="{DF579E7A-3F01-492E-A17D-EA01482057CA}"/>
               </a:ext>
             </a:extLst>
           </p:cNvPr>
@@ -5377,7 +5377,7 @@
           <p:cNvPr id="15" name="input-1">
             <a:extLst xmlns:a="http://schemas.openxmlformats.org/drawingml/2006/main">
               <a:ext uri="{FF2B5EF4-FFF2-40B4-BE49-F238E27FC236}">
-                <a16:creationId xmlns:a16="http://schemas.microsoft.com/office/drawing/2014/main" id="{09C27231-DEE0-459F-A0DE-AF78F1535E57}"/>
+                <a16:creationId xmlns:a16="http://schemas.microsoft.com/office/drawing/2014/main" id="{94088EF0-6E24-46CB-9FBE-75C590699504}"/>
               </a:ext>
             </a:extLst>
           </p:cNvPr>
@@ -5408,7 +5408,7 @@
           <p:cNvPr id="16" name="minute-1">
             <a:extLst xmlns:a="http://schemas.openxmlformats.org/drawingml/2006/main">
               <a:ext uri="{FF2B5EF4-FFF2-40B4-BE49-F238E27FC236}">
-                <a16:creationId xmlns:a16="http://schemas.microsoft.com/office/drawing/2014/main" id="{29544B49-B300-42D4-A07D-308A05BF64C3}"/>
+                <a16:creationId xmlns:a16="http://schemas.microsoft.com/office/drawing/2014/main" id="{93C0B26D-19CB-4A08-8D1F-51E655375231}"/>
               </a:ext>
             </a:extLst>
           </p:cNvPr>
@@ -5466,7 +5466,7 @@
           <p:cNvPr id="17" name="input-2">
             <a:extLst xmlns:a="http://schemas.openxmlformats.org/drawingml/2006/main">
               <a:ext uri="{FF2B5EF4-FFF2-40B4-BE49-F238E27FC236}">
-                <a16:creationId xmlns:a16="http://schemas.microsoft.com/office/drawing/2014/main" id="{DF855C2B-8853-4420-A3D8-7124CA49D70A}"/>
+                <a16:creationId xmlns:a16="http://schemas.microsoft.com/office/drawing/2014/main" id="{4FCD3F64-0558-4F0C-BBEF-0C702ACB362F}"/>
               </a:ext>
             </a:extLst>
           </p:cNvPr>
@@ -5497,7 +5497,7 @@
           <p:cNvPr id="18" name="minute-2">
             <a:extLst xmlns:a="http://schemas.openxmlformats.org/drawingml/2006/main">
               <a:ext uri="{FF2B5EF4-FFF2-40B4-BE49-F238E27FC236}">
-                <a16:creationId xmlns:a16="http://schemas.microsoft.com/office/drawing/2014/main" id="{F9A50981-4F80-4752-836D-4C9C22FE1094}"/>
+                <a16:creationId xmlns:a16="http://schemas.microsoft.com/office/drawing/2014/main" id="{37FEDC9E-D5C3-4A79-897C-6C2BA5718514}"/>
               </a:ext>
             </a:extLst>
           </p:cNvPr>
@@ -5555,7 +5555,7 @@
           <p:cNvPr id="19" name="input-3">
             <a:extLst xmlns:a="http://schemas.openxmlformats.org/drawingml/2006/main">
               <a:ext uri="{FF2B5EF4-FFF2-40B4-BE49-F238E27FC236}">
-                <a16:creationId xmlns:a16="http://schemas.microsoft.com/office/drawing/2014/main" id="{65C106FB-7811-4808-9A3B-A8581A93A4B0}"/>
+                <a16:creationId xmlns:a16="http://schemas.microsoft.com/office/drawing/2014/main" id="{9BAA00E3-4F96-4D44-866B-9B36FD784D91}"/>
               </a:ext>
             </a:extLst>
           </p:cNvPr>
@@ -5586,7 +5586,7 @@
           <p:cNvPr id="20" name="minute-3">
             <a:extLst xmlns:a="http://schemas.openxmlformats.org/drawingml/2006/main">
               <a:ext uri="{FF2B5EF4-FFF2-40B4-BE49-F238E27FC236}">
-                <a16:creationId xmlns:a16="http://schemas.microsoft.com/office/drawing/2014/main" id="{953DFDF5-A3CF-4C0A-8330-287218079E7B}"/>
+                <a16:creationId xmlns:a16="http://schemas.microsoft.com/office/drawing/2014/main" id="{FE1DDCEA-E1C7-4C55-BC6A-435E92E416C8}"/>
               </a:ext>
             </a:extLst>
           </p:cNvPr>
@@ -5644,7 +5644,7 @@
           <p:cNvPr id="21" name="input-4">
             <a:extLst xmlns:a="http://schemas.openxmlformats.org/drawingml/2006/main">
               <a:ext uri="{FF2B5EF4-FFF2-40B4-BE49-F238E27FC236}">
-                <a16:creationId xmlns:a16="http://schemas.microsoft.com/office/drawing/2014/main" id="{583BF31E-F914-4B2A-B526-F4E0CCF03224}"/>
+                <a16:creationId xmlns:a16="http://schemas.microsoft.com/office/drawing/2014/main" id="{71103603-BA66-4869-9769-8296A935C28C}"/>
               </a:ext>
             </a:extLst>
           </p:cNvPr>
@@ -5675,7 +5675,7 @@
           <p:cNvPr id="22" name="minute-4">
             <a:extLst xmlns:a="http://schemas.openxmlformats.org/drawingml/2006/main">
               <a:ext uri="{FF2B5EF4-FFF2-40B4-BE49-F238E27FC236}">
-                <a16:creationId xmlns:a16="http://schemas.microsoft.com/office/drawing/2014/main" id="{EF9E85FB-03A1-4AB3-94C7-D9F6A4407964}"/>
+                <a16:creationId xmlns:a16="http://schemas.microsoft.com/office/drawing/2014/main" id="{E90CCD6D-053E-4108-AFE0-D15AE65FE897}"/>
               </a:ext>
             </a:extLst>
           </p:cNvPr>
@@ -5733,7 +5733,7 @@
           <p:cNvPr id="23" name="input-5">
             <a:extLst xmlns:a="http://schemas.openxmlformats.org/drawingml/2006/main">
               <a:ext uri="{FF2B5EF4-FFF2-40B4-BE49-F238E27FC236}">
-                <a16:creationId xmlns:a16="http://schemas.microsoft.com/office/drawing/2014/main" id="{16B3B8F5-C612-4398-BBCF-CB8603BE80FA}"/>
+                <a16:creationId xmlns:a16="http://schemas.microsoft.com/office/drawing/2014/main" id="{A61447DB-95F1-4E7E-BF6F-7731149975D0}"/>
               </a:ext>
             </a:extLst>
           </p:cNvPr>
@@ -5764,7 +5764,7 @@
           <p:cNvPr id="24" name="minute-5">
             <a:extLst xmlns:a="http://schemas.openxmlformats.org/drawingml/2006/main">
               <a:ext uri="{FF2B5EF4-FFF2-40B4-BE49-F238E27FC236}">
-                <a16:creationId xmlns:a16="http://schemas.microsoft.com/office/drawing/2014/main" id="{89F14E31-BEA9-43DC-BADB-09177DE9180E}"/>
+                <a16:creationId xmlns:a16="http://schemas.microsoft.com/office/drawing/2014/main" id="{3A1710EB-ED52-4545-8794-91082E0F32E2}"/>
               </a:ext>
             </a:extLst>
           </p:cNvPr>
@@ -5822,7 +5822,7 @@
           <p:cNvPr id="25" name="retained-5">
             <a:extLst xmlns:a="http://schemas.openxmlformats.org/drawingml/2006/main">
               <a:ext uri="{FF2B5EF4-FFF2-40B4-BE49-F238E27FC236}">
-                <a16:creationId xmlns:a16="http://schemas.microsoft.com/office/drawing/2014/main" id="{CA9A171D-CF29-44C6-9592-D976CDDB8571}"/>
+                <a16:creationId xmlns:a16="http://schemas.microsoft.com/office/drawing/2014/main" id="{014D3880-17C7-4054-A1C1-4D1E59A37701}"/>
               </a:ext>
             </a:extLst>
           </p:cNvPr>
@@ -5880,7 +5880,7 @@
           <p:cNvPr id="27" name="input-6">
             <a:extLst xmlns:a="http://schemas.openxmlformats.org/drawingml/2006/main">
               <a:ext uri="{FF2B5EF4-FFF2-40B4-BE49-F238E27FC236}">
-                <a16:creationId xmlns:a16="http://schemas.microsoft.com/office/drawing/2014/main" id="{7980C339-F2BE-4E41-B247-60F8D84706F5}"/>
+                <a16:creationId xmlns:a16="http://schemas.microsoft.com/office/drawing/2014/main" id="{6208B83C-8FE2-4515-A2B3-7469D7721A41}"/>
               </a:ext>
             </a:extLst>
           </p:cNvPr>
@@ -5911,7 +5911,7 @@
           <p:cNvPr id="28" name="minute-6">
             <a:extLst xmlns:a="http://schemas.openxmlformats.org/drawingml/2006/main">
               <a:ext uri="{FF2B5EF4-FFF2-40B4-BE49-F238E27FC236}">
-                <a16:creationId xmlns:a16="http://schemas.microsoft.com/office/drawing/2014/main" id="{0DDB937B-825C-481D-9E16-3EF2ABDA8380}"/>
+                <a16:creationId xmlns:a16="http://schemas.microsoft.com/office/drawing/2014/main" id="{9B023A74-F71B-462F-BFAC-DD11759F6531}"/>
               </a:ext>
             </a:extLst>
           </p:cNvPr>
@@ -5969,7 +5969,7 @@
           <p:cNvPr id="29" name="input-7">
             <a:extLst xmlns:a="http://schemas.openxmlformats.org/drawingml/2006/main">
               <a:ext uri="{FF2B5EF4-FFF2-40B4-BE49-F238E27FC236}">
-                <a16:creationId xmlns:a16="http://schemas.microsoft.com/office/drawing/2014/main" id="{B382E472-DC79-4FCA-9FA5-584833BE2475}"/>
+                <a16:creationId xmlns:a16="http://schemas.microsoft.com/office/drawing/2014/main" id="{34C5F5AF-372E-4646-9568-5C95F2BAB3EE}"/>
               </a:ext>
             </a:extLst>
           </p:cNvPr>
@@ -6000,7 +6000,7 @@
           <p:cNvPr id="30" name="minute-7">
             <a:extLst xmlns:a="http://schemas.openxmlformats.org/drawingml/2006/main">
               <a:ext uri="{FF2B5EF4-FFF2-40B4-BE49-F238E27FC236}">
-                <a16:creationId xmlns:a16="http://schemas.microsoft.com/office/drawing/2014/main" id="{2D5C0F4B-5707-4BBD-ABB0-FB6D8451171E}"/>
+                <a16:creationId xmlns:a16="http://schemas.microsoft.com/office/drawing/2014/main" id="{C5E26298-6AB4-4305-A242-282D4AFDDD99}"/>
               </a:ext>
             </a:extLst>
           </p:cNvPr>
@@ -6058,7 +6058,7 @@
           <p:cNvPr id="31" name="input-8">
             <a:extLst xmlns:a="http://schemas.openxmlformats.org/drawingml/2006/main">
               <a:ext uri="{FF2B5EF4-FFF2-40B4-BE49-F238E27FC236}">
-                <a16:creationId xmlns:a16="http://schemas.microsoft.com/office/drawing/2014/main" id="{E61B9A16-1209-4744-B395-89A61F43435A}"/>
+                <a16:creationId xmlns:a16="http://schemas.microsoft.com/office/drawing/2014/main" id="{2ABB75BC-B65A-438A-BB00-238F7C7C77C8}"/>
               </a:ext>
             </a:extLst>
           </p:cNvPr>
@@ -6089,7 +6089,7 @@
           <p:cNvPr id="32" name="minute-8">
             <a:extLst xmlns:a="http://schemas.openxmlformats.org/drawingml/2006/main">
               <a:ext uri="{FF2B5EF4-FFF2-40B4-BE49-F238E27FC236}">
-                <a16:creationId xmlns:a16="http://schemas.microsoft.com/office/drawing/2014/main" id="{208ECD8C-28FB-4DB9-A689-2232AB5A1CDA}"/>
+                <a16:creationId xmlns:a16="http://schemas.microsoft.com/office/drawing/2014/main" id="{030A158D-63FB-44A7-B928-5D0C42B3F05F}"/>
               </a:ext>
             </a:extLst>
           </p:cNvPr>
@@ -6147,7 +6147,7 @@
           <p:cNvPr id="33" name="input-9">
             <a:extLst xmlns:a="http://schemas.openxmlformats.org/drawingml/2006/main">
               <a:ext uri="{FF2B5EF4-FFF2-40B4-BE49-F238E27FC236}">
-                <a16:creationId xmlns:a16="http://schemas.microsoft.com/office/drawing/2014/main" id="{EE7A1647-BDA5-4FE3-80E4-8D0BA21F8708}"/>
+                <a16:creationId xmlns:a16="http://schemas.microsoft.com/office/drawing/2014/main" id="{45BE156C-2315-41B3-AD4A-0D4EA669BB0C}"/>
               </a:ext>
             </a:extLst>
           </p:cNvPr>
@@ -6178,7 +6178,7 @@
           <p:cNvPr id="34" name="minute-9">
             <a:extLst xmlns:a="http://schemas.openxmlformats.org/drawingml/2006/main">
               <a:ext uri="{FF2B5EF4-FFF2-40B4-BE49-F238E27FC236}">
-                <a16:creationId xmlns:a16="http://schemas.microsoft.com/office/drawing/2014/main" id="{3F3A3364-FEDD-4E40-8729-6BDCD6E84E98}"/>
+                <a16:creationId xmlns:a16="http://schemas.microsoft.com/office/drawing/2014/main" id="{3E3C21C0-B8D7-4E94-8384-2F20255120F8}"/>
               </a:ext>
             </a:extLst>
           </p:cNvPr>
@@ -6236,7 +6236,7 @@
           <p:cNvPr id="35" name="input-10">
             <a:extLst xmlns:a="http://schemas.openxmlformats.org/drawingml/2006/main">
               <a:ext uri="{FF2B5EF4-FFF2-40B4-BE49-F238E27FC236}">
-                <a16:creationId xmlns:a16="http://schemas.microsoft.com/office/drawing/2014/main" id="{878493E5-DC2E-4767-BDAB-0A8715D14DCC}"/>
+                <a16:creationId xmlns:a16="http://schemas.microsoft.com/office/drawing/2014/main" id="{B5743F84-66BD-4229-851C-854CFC4A6272}"/>
               </a:ext>
             </a:extLst>
           </p:cNvPr>
@@ -6267,7 +6267,7 @@
           <p:cNvPr id="36" name="minute-10">
             <a:extLst xmlns:a="http://schemas.openxmlformats.org/drawingml/2006/main">
               <a:ext uri="{FF2B5EF4-FFF2-40B4-BE49-F238E27FC236}">
-                <a16:creationId xmlns:a16="http://schemas.microsoft.com/office/drawing/2014/main" id="{16AA224B-6F33-4F81-8D86-9D25E19F963C}"/>
+                <a16:creationId xmlns:a16="http://schemas.microsoft.com/office/drawing/2014/main" id="{97C82175-EB85-46EF-B89E-2FC4DD599212}"/>
               </a:ext>
             </a:extLst>
           </p:cNvPr>
@@ -6325,7 +6325,7 @@
           <p:cNvPr id="37" name="retained-10">
             <a:extLst xmlns:a="http://schemas.openxmlformats.org/drawingml/2006/main">
               <a:ext uri="{FF2B5EF4-FFF2-40B4-BE49-F238E27FC236}">
-                <a16:creationId xmlns:a16="http://schemas.microsoft.com/office/drawing/2014/main" id="{DCAD5104-2C6C-4EDC-B88B-D19305FB5385}"/>
+                <a16:creationId xmlns:a16="http://schemas.microsoft.com/office/drawing/2014/main" id="{7447CB29-BEE7-40CF-98E1-BE85AC49712E}"/>
               </a:ext>
             </a:extLst>
           </p:cNvPr>
@@ -6383,7 +6383,7 @@
           <p:cNvPr id="39" name="input-11">
             <a:extLst xmlns:a="http://schemas.openxmlformats.org/drawingml/2006/main">
               <a:ext uri="{FF2B5EF4-FFF2-40B4-BE49-F238E27FC236}">
-                <a16:creationId xmlns:a16="http://schemas.microsoft.com/office/drawing/2014/main" id="{0844FA5A-C7A1-4916-9E9E-60EFFE449182}"/>
+                <a16:creationId xmlns:a16="http://schemas.microsoft.com/office/drawing/2014/main" id="{57CD2F03-5A37-41B4-9FCB-BB6A58698EDB}"/>
               </a:ext>
             </a:extLst>
           </p:cNvPr>
@@ -6414,7 +6414,7 @@
           <p:cNvPr id="40" name="minute-11">
             <a:extLst xmlns:a="http://schemas.openxmlformats.org/drawingml/2006/main">
               <a:ext uri="{FF2B5EF4-FFF2-40B4-BE49-F238E27FC236}">
-                <a16:creationId xmlns:a16="http://schemas.microsoft.com/office/drawing/2014/main" id="{CC76DB99-C936-43BF-82CB-FF1B1466F9B9}"/>
+                <a16:creationId xmlns:a16="http://schemas.microsoft.com/office/drawing/2014/main" id="{777B0460-442C-47F4-99D2-A5A19C3986A8}"/>
               </a:ext>
             </a:extLst>
           </p:cNvPr>
@@ -6472,7 +6472,7 @@
           <p:cNvPr id="41" name="input-12">
             <a:extLst xmlns:a="http://schemas.openxmlformats.org/drawingml/2006/main">
               <a:ext uri="{FF2B5EF4-FFF2-40B4-BE49-F238E27FC236}">
-                <a16:creationId xmlns:a16="http://schemas.microsoft.com/office/drawing/2014/main" id="{81704F39-36C7-4F5D-BD81-7D23EDE02DC3}"/>
+                <a16:creationId xmlns:a16="http://schemas.microsoft.com/office/drawing/2014/main" id="{9C48AAF3-CE1A-4E00-98D6-23345C580F2F}"/>
               </a:ext>
             </a:extLst>
           </p:cNvPr>
@@ -6503,7 +6503,7 @@
           <p:cNvPr id="42" name="minute-12">
             <a:extLst xmlns:a="http://schemas.openxmlformats.org/drawingml/2006/main">
               <a:ext uri="{FF2B5EF4-FFF2-40B4-BE49-F238E27FC236}">
-                <a16:creationId xmlns:a16="http://schemas.microsoft.com/office/drawing/2014/main" id="{6C7F1E4F-085F-4EB6-8817-96D6CE6BE161}"/>
+                <a16:creationId xmlns:a16="http://schemas.microsoft.com/office/drawing/2014/main" id="{88CAD8D8-15C8-4E8B-B4CC-EECDE61B747A}"/>
               </a:ext>
             </a:extLst>
           </p:cNvPr>
@@ -6561,7 +6561,7 @@
           <p:cNvPr id="43" name="axis-unit">
             <a:extLst xmlns:a="http://schemas.openxmlformats.org/drawingml/2006/main">
               <a:ext uri="{FF2B5EF4-FFF2-40B4-BE49-F238E27FC236}">
-                <a16:creationId xmlns:a16="http://schemas.microsoft.com/office/drawing/2014/main" id="{6E1919AF-2436-418E-A3A1-9968D174272B}"/>
+                <a16:creationId xmlns:a16="http://schemas.microsoft.com/office/drawing/2014/main" id="{26E5015F-6A62-47B7-820E-CD73BD9F3A2B}"/>
               </a:ext>
             </a:extLst>
           </p:cNvPr>
@@ -6619,7 +6619,7 @@
           <p:cNvPr id="44" name="arrow-meaning">
             <a:extLst xmlns:a="http://schemas.openxmlformats.org/drawingml/2006/main">
               <a:ext uri="{FF2B5EF4-FFF2-40B4-BE49-F238E27FC236}">
-                <a16:creationId xmlns:a16="http://schemas.microsoft.com/office/drawing/2014/main" id="{543CFC32-CC90-4D76-99F0-B1538B8C7397}"/>
+                <a16:creationId xmlns:a16="http://schemas.microsoft.com/office/drawing/2014/main" id="{ECCF2DD9-021D-4A54-A8E9-06B11021898F}"/>
               </a:ext>
             </a:extLst>
           </p:cNvPr>
@@ -6677,7 +6677,7 @@
           <p:cNvPr id="45" name="source-note">
             <a:extLst xmlns:a="http://schemas.openxmlformats.org/drawingml/2006/main">
               <a:ext uri="{FF2B5EF4-FFF2-40B4-BE49-F238E27FC236}">
-                <a16:creationId xmlns:a16="http://schemas.microsoft.com/office/drawing/2014/main" id="{AB706DFE-0FB0-48CC-A83F-96880211C335}"/>
+                <a16:creationId xmlns:a16="http://schemas.microsoft.com/office/drawing/2014/main" id="{9CFCADFE-DFF5-4003-8A48-A6931758B3D3}"/>
               </a:ext>
             </a:extLst>
           </p:cNvPr>
@@ -6735,7 +6735,7 @@
           <p:cNvPr id="46" name="page-reference">
             <a:extLst xmlns:a="http://schemas.openxmlformats.org/drawingml/2006/main">
               <a:ext uri="{FF2B5EF4-FFF2-40B4-BE49-F238E27FC236}">
-                <a16:creationId xmlns:a16="http://schemas.microsoft.com/office/drawing/2014/main" id="{8520B2F2-E973-4CE1-8D74-170000086AB4}"/>
+                <a16:creationId xmlns:a16="http://schemas.microsoft.com/office/drawing/2014/main" id="{3BC9D3AE-2010-4D86-B98B-7E0CE721E6D1}"/>
               </a:ext>
             </a:extLst>
           </p:cNvPr>
@@ -6791,7 +6791,7 @@
     </p:spTree>
     <p:extLst>
       <p:ext uri="{BB962C8B-B14F-4D97-AF65-F5344CB8AC3E}">
-        <p14:creationId xmlns:p14="http://schemas.microsoft.com/office/powerpoint/2010/main" val="2100156097"/>
+        <p14:creationId xmlns:p14="http://schemas.microsoft.com/office/powerpoint/2010/main" val="458776401"/>
       </p:ext>
     </p:extLst>
   </p:cSld>
@@ -6822,7 +6822,7 @@
           <p:cNvPr id="15" name="footer-line">
             <a:extLst xmlns:a="http://schemas.openxmlformats.org/drawingml/2006/main">
               <a:ext uri="{FF2B5EF4-FFF2-40B4-BE49-F238E27FC236}">
-                <a16:creationId xmlns:a16="http://schemas.microsoft.com/office/drawing/2014/main" id="{E1C12BEF-8A63-4221-9669-2D2986D8B6BC}"/>
+                <a16:creationId xmlns:a16="http://schemas.microsoft.com/office/drawing/2014/main" id="{3BD7633A-928D-45DB-A2EB-AD01BAF92796}"/>
               </a:ext>
             </a:extLst>
           </p:cNvPr>
@@ -6857,7 +6857,7 @@
           <p:nvPr/>
         </p:nvPicPr>
         <p:blipFill>
-          <a:blip xmlns:r="http://schemas.openxmlformats.org/officeDocument/2006/relationships" xmlns:a="http://schemas.openxmlformats.org/drawingml/2006/main" r:embed="Rff5a6015d2034b2e"/>
+          <a:blip xmlns:r="http://schemas.openxmlformats.org/officeDocument/2006/relationships" xmlns:a="http://schemas.openxmlformats.org/drawingml/2006/main" r:embed="Rc8aea665ea9b4bd6"/>
           <a:stretch xmlns:a="http://schemas.openxmlformats.org/drawingml/2006/main"/>
         </p:blipFill>
         <p:spPr>
@@ -6875,7 +6875,7 @@
           <p:cNvPr id="3" name="page">
             <a:extLst xmlns:a="http://schemas.openxmlformats.org/drawingml/2006/main">
               <a:ext uri="{FF2B5EF4-FFF2-40B4-BE49-F238E27FC236}">
-                <a16:creationId xmlns:a16="http://schemas.microsoft.com/office/drawing/2014/main" id="{CD8BDB91-D142-40FC-84F8-726FA449E2E1}"/>
+                <a16:creationId xmlns:a16="http://schemas.microsoft.com/office/drawing/2014/main" id="{5D9EAB48-0891-4328-B278-7F5F44F9784F}"/>
               </a:ext>
             </a:extLst>
           </p:cNvPr>
@@ -6933,7 +6933,7 @@
           <p:cNvPr id="4" name="fictional-disclosure">
             <a:extLst xmlns:a="http://schemas.openxmlformats.org/drawingml/2006/main">
               <a:ext uri="{FF2B5EF4-FFF2-40B4-BE49-F238E27FC236}">
-                <a16:creationId xmlns:a16="http://schemas.microsoft.com/office/drawing/2014/main" id="{EEF31DD0-9C4F-4A16-865F-39130CD2C2A1}"/>
+                <a16:creationId xmlns:a16="http://schemas.microsoft.com/office/drawing/2014/main" id="{14CD8C17-925F-4EF7-9116-B52BD703A638}"/>
               </a:ext>
             </a:extLst>
           </p:cNvPr>
@@ -6991,7 +6991,7 @@
           <p:cNvPr id="5" name="running-chapter-6">
             <a:extLst xmlns:a="http://schemas.openxmlformats.org/drawingml/2006/main">
               <a:ext uri="{FF2B5EF4-FFF2-40B4-BE49-F238E27FC236}">
-                <a16:creationId xmlns:a16="http://schemas.microsoft.com/office/drawing/2014/main" id="{FEC1C188-F101-4023-A0CF-937F1280629B}"/>
+                <a16:creationId xmlns:a16="http://schemas.microsoft.com/office/drawing/2014/main" id="{C9A418BD-F310-43D7-94A9-132CEBDD092C}"/>
               </a:ext>
             </a:extLst>
           </p:cNvPr>
@@ -7049,7 +7049,7 @@
           <p:cNvPr id="6" name="running-title-6">
             <a:extLst xmlns:a="http://schemas.openxmlformats.org/drawingml/2006/main">
               <a:ext uri="{FF2B5EF4-FFF2-40B4-BE49-F238E27FC236}">
-                <a16:creationId xmlns:a16="http://schemas.microsoft.com/office/drawing/2014/main" id="{57527F54-78DD-4349-8B38-D54CDA4E689C}"/>
+                <a16:creationId xmlns:a16="http://schemas.microsoft.com/office/drawing/2014/main" id="{A8E13E9D-40B6-4C0B-8FD0-A425DC214316}"/>
               </a:ext>
             </a:extLst>
           </p:cNvPr>
@@ -7107,7 +7107,7 @@
           <p:cNvPr id="7" name="title">
             <a:extLst xmlns:a="http://schemas.openxmlformats.org/drawingml/2006/main">
               <a:ext uri="{FF2B5EF4-FFF2-40B4-BE49-F238E27FC236}">
-                <a16:creationId xmlns:a16="http://schemas.microsoft.com/office/drawing/2014/main" id="{30FD4D1D-E703-4B8C-A10F-7C51628EAD70}"/>
+                <a16:creationId xmlns:a16="http://schemas.microsoft.com/office/drawing/2014/main" id="{A42752C1-8141-4B84-A82F-620406966C90}"/>
               </a:ext>
             </a:extLst>
           </p:cNvPr>
@@ -7165,7 +7165,7 @@
           <p:cNvPr id="8" name="message">
             <a:extLst xmlns:a="http://schemas.openxmlformats.org/drawingml/2006/main">
               <a:ext uri="{FF2B5EF4-FFF2-40B4-BE49-F238E27FC236}">
-                <a16:creationId xmlns:a16="http://schemas.microsoft.com/office/drawing/2014/main" id="{430A116E-0C0C-4EF3-9F9C-F2B52C0E06E4}"/>
+                <a16:creationId xmlns:a16="http://schemas.microsoft.com/office/drawing/2014/main" id="{1C7710A1-DA06-4584-B24D-64427DBE046E}"/>
               </a:ext>
             </a:extLst>
           </p:cNvPr>
@@ -7230,7 +7230,7 @@
         </p:xfrm>
         <a:graphic xmlns:a="http://schemas.openxmlformats.org/drawingml/2006/main">
           <a:graphicData uri="http://schemas.openxmlformats.org/drawingml/2006/chart">
-            <c:chart xmlns:r="http://schemas.openxmlformats.org/officeDocument/2006/relationships" xmlns:c="http://schemas.openxmlformats.org/drawingml/2006/chart" r:id="Rf543687b78ea4063"/>
+            <c:chart xmlns:r="http://schemas.openxmlformats.org/officeDocument/2006/relationships" xmlns:c="http://schemas.openxmlformats.org/drawingml/2006/chart" r:id="R326fbe63a74c4c34"/>
           </a:graphicData>
         </a:graphic>
       </p:graphicFrame>
@@ -7239,7 +7239,7 @@
           <p:cNvPr id="10" name="maximum-label">
             <a:extLst xmlns:a="http://schemas.openxmlformats.org/drawingml/2006/main">
               <a:ext uri="{FF2B5EF4-FFF2-40B4-BE49-F238E27FC236}">
-                <a16:creationId xmlns:a16="http://schemas.microsoft.com/office/drawing/2014/main" id="{E3D40DB3-98CE-4CBF-A9B8-F0C9EFCB0C1F}"/>
+                <a16:creationId xmlns:a16="http://schemas.microsoft.com/office/drawing/2014/main" id="{60492021-5ECB-4769-8202-CAF39105AA7C}"/>
               </a:ext>
             </a:extLst>
           </p:cNvPr>
@@ -7297,7 +7297,7 @@
           <p:cNvPr id="11" name="all-max">
             <a:extLst xmlns:a="http://schemas.openxmlformats.org/drawingml/2006/main">
               <a:ext uri="{FF2B5EF4-FFF2-40B4-BE49-F238E27FC236}">
-                <a16:creationId xmlns:a16="http://schemas.microsoft.com/office/drawing/2014/main" id="{AF0B4DD4-DFA6-485E-A736-2158875006EA}"/>
+                <a16:creationId xmlns:a16="http://schemas.microsoft.com/office/drawing/2014/main" id="{16B77EF2-E10F-4F6D-B98A-57FD18195D77}"/>
               </a:ext>
             </a:extLst>
           </p:cNvPr>
@@ -7378,7 +7378,7 @@
           <p:cNvPr id="12" name="kept-max">
             <a:extLst xmlns:a="http://schemas.openxmlformats.org/drawingml/2006/main">
               <a:ext uri="{FF2B5EF4-FFF2-40B4-BE49-F238E27FC236}">
-                <a16:creationId xmlns:a16="http://schemas.microsoft.com/office/drawing/2014/main" id="{E49E125F-A346-46A6-B343-83A74B0E204E}"/>
+                <a16:creationId xmlns:a16="http://schemas.microsoft.com/office/drawing/2014/main" id="{BE3705AD-FEF5-41F0-8D22-EC6FE1377DCB}"/>
               </a:ext>
             </a:extLst>
           </p:cNvPr>
@@ -7459,7 +7459,7 @@
           <p:cNvPr id="13" name="condition">
             <a:extLst xmlns:a="http://schemas.openxmlformats.org/drawingml/2006/main">
               <a:ext uri="{FF2B5EF4-FFF2-40B4-BE49-F238E27FC236}">
-                <a16:creationId xmlns:a16="http://schemas.microsoft.com/office/drawing/2014/main" id="{BF0B51A0-39A5-4C63-9ACE-ACB966323C12}"/>
+                <a16:creationId xmlns:a16="http://schemas.microsoft.com/office/drawing/2014/main" id="{714756F9-AA1E-45E3-92F6-E01C4E420DEE}"/>
               </a:ext>
             </a:extLst>
           </p:cNvPr>
@@ -7517,7 +7517,7 @@
           <p:cNvPr id="14" name="page-reference">
             <a:extLst xmlns:a="http://schemas.openxmlformats.org/drawingml/2006/main">
               <a:ext uri="{FF2B5EF4-FFF2-40B4-BE49-F238E27FC236}">
-                <a16:creationId xmlns:a16="http://schemas.microsoft.com/office/drawing/2014/main" id="{B2325127-C7E8-44C9-8B6E-E2903C3792DE}"/>
+                <a16:creationId xmlns:a16="http://schemas.microsoft.com/office/drawing/2014/main" id="{1E2D8D7A-4995-4024-9515-E31392D6A967}"/>
               </a:ext>
             </a:extLst>
           </p:cNvPr>
@@ -7573,7 +7573,7 @@
     </p:spTree>
     <p:extLst>
       <p:ext uri="{BB962C8B-B14F-4D97-AF65-F5344CB8AC3E}">
-        <p14:creationId xmlns:p14="http://schemas.microsoft.com/office/powerpoint/2010/main" val="1042603017"/>
+        <p14:creationId xmlns:p14="http://schemas.microsoft.com/office/powerpoint/2010/main" val="451810699"/>
       </p:ext>
     </p:extLst>
   </p:cSld>
@@ -7604,7 +7604,7 @@
           <p:cNvPr id="12" name="footer-line">
             <a:extLst xmlns:a="http://schemas.openxmlformats.org/drawingml/2006/main">
               <a:ext uri="{FF2B5EF4-FFF2-40B4-BE49-F238E27FC236}">
-                <a16:creationId xmlns:a16="http://schemas.microsoft.com/office/drawing/2014/main" id="{E73201DD-DFCB-4ABD-A04E-94DAF4C477FE}"/>
+                <a16:creationId xmlns:a16="http://schemas.microsoft.com/office/drawing/2014/main" id="{3DE56213-2E5D-4836-A834-D67CBD4561E8}"/>
               </a:ext>
             </a:extLst>
           </p:cNvPr>
@@ -7639,7 +7639,7 @@
           <p:nvPr/>
         </p:nvPicPr>
         <p:blipFill>
-          <a:blip xmlns:r="http://schemas.openxmlformats.org/officeDocument/2006/relationships" xmlns:a="http://schemas.openxmlformats.org/drawingml/2006/main" r:embed="R9f41ed48425141e7"/>
+          <a:blip xmlns:r="http://schemas.openxmlformats.org/officeDocument/2006/relationships" xmlns:a="http://schemas.openxmlformats.org/drawingml/2006/main" r:embed="R5bb134d10283475c"/>
           <a:stretch xmlns:a="http://schemas.openxmlformats.org/drawingml/2006/main"/>
         </p:blipFill>
         <p:spPr>
@@ -7657,7 +7657,7 @@
           <p:cNvPr id="3" name="page">
             <a:extLst xmlns:a="http://schemas.openxmlformats.org/drawingml/2006/main">
               <a:ext uri="{FF2B5EF4-FFF2-40B4-BE49-F238E27FC236}">
-                <a16:creationId xmlns:a16="http://schemas.microsoft.com/office/drawing/2014/main" id="{6BE37E84-827C-4643-A611-F02FF40BBDF6}"/>
+                <a16:creationId xmlns:a16="http://schemas.microsoft.com/office/drawing/2014/main" id="{FBA2F4A0-CDDB-4050-929B-F63F3D98D802}"/>
               </a:ext>
             </a:extLst>
           </p:cNvPr>
@@ -7715,7 +7715,7 @@
           <p:cNvPr id="4" name="fictional-disclosure">
             <a:extLst xmlns:a="http://schemas.openxmlformats.org/drawingml/2006/main">
               <a:ext uri="{FF2B5EF4-FFF2-40B4-BE49-F238E27FC236}">
-                <a16:creationId xmlns:a16="http://schemas.microsoft.com/office/drawing/2014/main" id="{BD0AB5BD-9D7B-4A18-A1DB-229A0905B456}"/>
+                <a16:creationId xmlns:a16="http://schemas.microsoft.com/office/drawing/2014/main" id="{2F85D408-7271-45DE-8BB9-B3201F960030}"/>
               </a:ext>
             </a:extLst>
           </p:cNvPr>
@@ -7773,7 +7773,7 @@
           <p:cNvPr id="5" name="running-chapter-7">
             <a:extLst xmlns:a="http://schemas.openxmlformats.org/drawingml/2006/main">
               <a:ext uri="{FF2B5EF4-FFF2-40B4-BE49-F238E27FC236}">
-                <a16:creationId xmlns:a16="http://schemas.microsoft.com/office/drawing/2014/main" id="{BE1C479F-2725-4B37-B065-D6791332D8CA}"/>
+                <a16:creationId xmlns:a16="http://schemas.microsoft.com/office/drawing/2014/main" id="{1B6348E1-A2AC-40D4-AC06-0302385EC49C}"/>
               </a:ext>
             </a:extLst>
           </p:cNvPr>
@@ -7831,7 +7831,7 @@
           <p:cNvPr id="6" name="running-title-7">
             <a:extLst xmlns:a="http://schemas.openxmlformats.org/drawingml/2006/main">
               <a:ext uri="{FF2B5EF4-FFF2-40B4-BE49-F238E27FC236}">
-                <a16:creationId xmlns:a16="http://schemas.microsoft.com/office/drawing/2014/main" id="{8BB7C9A6-83DA-4BF9-AE4E-61AE3418E256}"/>
+                <a16:creationId xmlns:a16="http://schemas.microsoft.com/office/drawing/2014/main" id="{73DE0CE4-F36A-4C10-8A06-4792C6607044}"/>
               </a:ext>
             </a:extLst>
           </p:cNvPr>
@@ -7889,7 +7889,7 @@
           <p:cNvPr id="7" name="title">
             <a:extLst xmlns:a="http://schemas.openxmlformats.org/drawingml/2006/main">
               <a:ext uri="{FF2B5EF4-FFF2-40B4-BE49-F238E27FC236}">
-                <a16:creationId xmlns:a16="http://schemas.microsoft.com/office/drawing/2014/main" id="{AD927420-FE13-4C0E-9801-1959F952876C}"/>
+                <a16:creationId xmlns:a16="http://schemas.microsoft.com/office/drawing/2014/main" id="{7D8276D5-F619-4EE0-A6BE-F07D8477495C}"/>
               </a:ext>
             </a:extLst>
           </p:cNvPr>
@@ -7947,7 +7947,7 @@
           <p:cNvPr id="8" name="message">
             <a:extLst xmlns:a="http://schemas.openxmlformats.org/drawingml/2006/main">
               <a:ext uri="{FF2B5EF4-FFF2-40B4-BE49-F238E27FC236}">
-                <a16:creationId xmlns:a16="http://schemas.microsoft.com/office/drawing/2014/main" id="{349EA91B-E58A-420E-9B70-CD6D8B66F221}"/>
+                <a16:creationId xmlns:a16="http://schemas.microsoft.com/office/drawing/2014/main" id="{575549A4-1993-42B2-A6DD-28B39F7B2E2E}"/>
               </a:ext>
             </a:extLst>
           </p:cNvPr>
@@ -8336,7 +8336,7 @@
           <p:cNvPr id="10" name="scope">
             <a:extLst xmlns:a="http://schemas.openxmlformats.org/drawingml/2006/main">
               <a:ext uri="{FF2B5EF4-FFF2-40B4-BE49-F238E27FC236}">
-                <a16:creationId xmlns:a16="http://schemas.microsoft.com/office/drawing/2014/main" id="{C981BC55-1633-479C-A25D-36F708011BBC}"/>
+                <a16:creationId xmlns:a16="http://schemas.microsoft.com/office/drawing/2014/main" id="{A556260A-DC57-4398-8608-599E673ACB0D}"/>
               </a:ext>
             </a:extLst>
           </p:cNvPr>
@@ -8394,7 +8394,7 @@
           <p:cNvPr id="11" name="page-reference">
             <a:extLst xmlns:a="http://schemas.openxmlformats.org/drawingml/2006/main">
               <a:ext uri="{FF2B5EF4-FFF2-40B4-BE49-F238E27FC236}">
-                <a16:creationId xmlns:a16="http://schemas.microsoft.com/office/drawing/2014/main" id="{5042B5B5-0225-4655-8BB9-8D3718749478}"/>
+                <a16:creationId xmlns:a16="http://schemas.microsoft.com/office/drawing/2014/main" id="{3D460294-F3B6-4B21-9D8C-784DD0A93864}"/>
               </a:ext>
             </a:extLst>
           </p:cNvPr>
@@ -8450,7 +8450,7 @@
     </p:spTree>
     <p:extLst>
       <p:ext uri="{BB962C8B-B14F-4D97-AF65-F5344CB8AC3E}">
-        <p14:creationId xmlns:p14="http://schemas.microsoft.com/office/powerpoint/2010/main" val="1353474342"/>
+        <p14:creationId xmlns:p14="http://schemas.microsoft.com/office/powerpoint/2010/main" val="1741192396"/>
       </p:ext>
     </p:extLst>
   </p:cSld>
@@ -8481,7 +8481,7 @@
           <p:cNvPr id="21" name="footer-line">
             <a:extLst xmlns:a="http://schemas.openxmlformats.org/drawingml/2006/main">
               <a:ext uri="{FF2B5EF4-FFF2-40B4-BE49-F238E27FC236}">
-                <a16:creationId xmlns:a16="http://schemas.microsoft.com/office/drawing/2014/main" id="{3030BB74-F665-4286-8D83-C3365959132A}"/>
+                <a16:creationId xmlns:a16="http://schemas.microsoft.com/office/drawing/2014/main" id="{3C720CF8-6C7E-4529-B286-1DD6BCB9D043}"/>
               </a:ext>
             </a:extLst>
           </p:cNvPr>
@@ -8516,7 +8516,7 @@
           <p:nvPr/>
         </p:nvPicPr>
         <p:blipFill>
-          <a:blip xmlns:r="http://schemas.openxmlformats.org/officeDocument/2006/relationships" xmlns:a="http://schemas.openxmlformats.org/drawingml/2006/main" r:embed="Re5dc75871b2e454c"/>
+          <a:blip xmlns:r="http://schemas.openxmlformats.org/officeDocument/2006/relationships" xmlns:a="http://schemas.openxmlformats.org/drawingml/2006/main" r:embed="Rb4b30af7d9b74290"/>
           <a:stretch xmlns:a="http://schemas.openxmlformats.org/drawingml/2006/main"/>
         </p:blipFill>
         <p:spPr>
@@ -8534,7 +8534,7 @@
           <p:cNvPr id="3" name="page">
             <a:extLst xmlns:a="http://schemas.openxmlformats.org/drawingml/2006/main">
               <a:ext uri="{FF2B5EF4-FFF2-40B4-BE49-F238E27FC236}">
-                <a16:creationId xmlns:a16="http://schemas.microsoft.com/office/drawing/2014/main" id="{9F6DDA29-E2AC-4A1B-AF01-DE0D49A45899}"/>
+                <a16:creationId xmlns:a16="http://schemas.microsoft.com/office/drawing/2014/main" id="{F33A6DD1-89D9-4C48-9A89-60ECB483336D}"/>
               </a:ext>
             </a:extLst>
           </p:cNvPr>
@@ -8592,7 +8592,7 @@
           <p:cNvPr id="4" name="fictional-disclosure">
             <a:extLst xmlns:a="http://schemas.openxmlformats.org/drawingml/2006/main">
               <a:ext uri="{FF2B5EF4-FFF2-40B4-BE49-F238E27FC236}">
-                <a16:creationId xmlns:a16="http://schemas.microsoft.com/office/drawing/2014/main" id="{2D9EE0FE-8B1B-4146-8CCE-F9135C505137}"/>
+                <a16:creationId xmlns:a16="http://schemas.microsoft.com/office/drawing/2014/main" id="{BAF07CE1-6DC9-46DC-A872-267F61C4AD79}"/>
               </a:ext>
             </a:extLst>
           </p:cNvPr>
@@ -8650,7 +8650,7 @@
           <p:cNvPr id="5" name="running-chapter-8">
             <a:extLst xmlns:a="http://schemas.openxmlformats.org/drawingml/2006/main">
               <a:ext uri="{FF2B5EF4-FFF2-40B4-BE49-F238E27FC236}">
-                <a16:creationId xmlns:a16="http://schemas.microsoft.com/office/drawing/2014/main" id="{AACAB00F-28CB-4784-816E-50AD94916A8E}"/>
+                <a16:creationId xmlns:a16="http://schemas.microsoft.com/office/drawing/2014/main" id="{B0524B17-9E93-4272-B27F-C20FCC348785}"/>
               </a:ext>
             </a:extLst>
           </p:cNvPr>
@@ -8708,7 +8708,7 @@
           <p:cNvPr id="6" name="running-title-8">
             <a:extLst xmlns:a="http://schemas.openxmlformats.org/drawingml/2006/main">
               <a:ext uri="{FF2B5EF4-FFF2-40B4-BE49-F238E27FC236}">
-                <a16:creationId xmlns:a16="http://schemas.microsoft.com/office/drawing/2014/main" id="{F6F9BDF7-020B-4CE0-AD9F-9CD5347C818D}"/>
+                <a16:creationId xmlns:a16="http://schemas.microsoft.com/office/drawing/2014/main" id="{33D6B34A-1DD5-450E-BC47-CC0D225E58F7}"/>
               </a:ext>
             </a:extLst>
           </p:cNvPr>
@@ -8766,7 +8766,7 @@
           <p:cNvPr id="7" name="title">
             <a:extLst xmlns:a="http://schemas.openxmlformats.org/drawingml/2006/main">
               <a:ext uri="{FF2B5EF4-FFF2-40B4-BE49-F238E27FC236}">
-                <a16:creationId xmlns:a16="http://schemas.microsoft.com/office/drawing/2014/main" id="{D8DEC442-7408-4E60-A2F4-B8E79F3FADE1}"/>
+                <a16:creationId xmlns:a16="http://schemas.microsoft.com/office/drawing/2014/main" id="{096BEA23-0C1D-40DF-83EF-536F47F9DA9F}"/>
               </a:ext>
             </a:extLst>
           </p:cNvPr>
@@ -8824,7 +8824,7 @@
           <p:cNvPr id="8" name="message">
             <a:extLst xmlns:a="http://schemas.openxmlformats.org/drawingml/2006/main">
               <a:ext uri="{FF2B5EF4-FFF2-40B4-BE49-F238E27FC236}">
-                <a16:creationId xmlns:a16="http://schemas.microsoft.com/office/drawing/2014/main" id="{A9BED28E-10D4-4276-946E-D373CA40683A}"/>
+                <a16:creationId xmlns:a16="http://schemas.microsoft.com/office/drawing/2014/main" id="{DAF9EDCF-DF1A-4517-BDC9-45E80485DCD9}"/>
               </a:ext>
             </a:extLst>
           </p:cNvPr>
@@ -8882,7 +8882,7 @@
           <p:cNvPr id="9" name="summary-label-0">
             <a:extLst xmlns:a="http://schemas.openxmlformats.org/drawingml/2006/main">
               <a:ext uri="{FF2B5EF4-FFF2-40B4-BE49-F238E27FC236}">
-                <a16:creationId xmlns:a16="http://schemas.microsoft.com/office/drawing/2014/main" id="{7E98C2AB-1815-4608-B389-442566C2C096}"/>
+                <a16:creationId xmlns:a16="http://schemas.microsoft.com/office/drawing/2014/main" id="{3A783194-87A0-4FC0-A82F-82AD6BE591BE}"/>
               </a:ext>
             </a:extLst>
           </p:cNvPr>
@@ -8940,7 +8940,7 @@
           <p:cNvPr id="10" name="summary-body-0">
             <a:extLst xmlns:a="http://schemas.openxmlformats.org/drawingml/2006/main">
               <a:ext uri="{FF2B5EF4-FFF2-40B4-BE49-F238E27FC236}">
-                <a16:creationId xmlns:a16="http://schemas.microsoft.com/office/drawing/2014/main" id="{4295BE24-24EF-4CC0-B6A5-188D78470C69}"/>
+                <a16:creationId xmlns:a16="http://schemas.microsoft.com/office/drawing/2014/main" id="{D082D373-8D65-4ADA-A908-7707102AA784}"/>
               </a:ext>
             </a:extLst>
           </p:cNvPr>
@@ -8998,7 +8998,7 @@
           <p:cNvPr id="11" name="summary-rule-0">
             <a:extLst xmlns:a="http://schemas.openxmlformats.org/drawingml/2006/main">
               <a:ext uri="{FF2B5EF4-FFF2-40B4-BE49-F238E27FC236}">
-                <a16:creationId xmlns:a16="http://schemas.microsoft.com/office/drawing/2014/main" id="{1E058072-7A7B-4112-8D6E-492C5C857EB1}"/>
+                <a16:creationId xmlns:a16="http://schemas.microsoft.com/office/drawing/2014/main" id="{6BE74239-CB43-4247-902C-9C431DA96CDA}"/>
               </a:ext>
             </a:extLst>
           </p:cNvPr>
@@ -9029,7 +9029,7 @@
           <p:cNvPr id="12" name="summary-label-1">
             <a:extLst xmlns:a="http://schemas.openxmlformats.org/drawingml/2006/main">
               <a:ext uri="{FF2B5EF4-FFF2-40B4-BE49-F238E27FC236}">
-                <a16:creationId xmlns:a16="http://schemas.microsoft.com/office/drawing/2014/main" id="{58EC75D8-F37E-4BAB-8D4B-8343A2593FDB}"/>
+                <a16:creationId xmlns:a16="http://schemas.microsoft.com/office/drawing/2014/main" id="{54CBECBF-F31A-4FAE-926B-C9BB96C62518}"/>
               </a:ext>
             </a:extLst>
           </p:cNvPr>
@@ -9087,7 +9087,7 @@
           <p:cNvPr id="13" name="summary-body-1">
             <a:extLst xmlns:a="http://schemas.openxmlformats.org/drawingml/2006/main">
               <a:ext uri="{FF2B5EF4-FFF2-40B4-BE49-F238E27FC236}">
-                <a16:creationId xmlns:a16="http://schemas.microsoft.com/office/drawing/2014/main" id="{A89FD6C2-CE10-4D5C-ADD7-44BF43E90B12}"/>
+                <a16:creationId xmlns:a16="http://schemas.microsoft.com/office/drawing/2014/main" id="{CC1DDDC9-A17A-4665-AC31-E8CF28393BF7}"/>
               </a:ext>
             </a:extLst>
           </p:cNvPr>
@@ -9145,7 +9145,7 @@
           <p:cNvPr id="14" name="summary-rule-1">
             <a:extLst xmlns:a="http://schemas.openxmlformats.org/drawingml/2006/main">
               <a:ext uri="{FF2B5EF4-FFF2-40B4-BE49-F238E27FC236}">
-                <a16:creationId xmlns:a16="http://schemas.microsoft.com/office/drawing/2014/main" id="{2588E751-1078-4859-8D66-74719659E291}"/>
+                <a16:creationId xmlns:a16="http://schemas.microsoft.com/office/drawing/2014/main" id="{9481BB39-1D3C-449E-B443-2ABFE9508CDC}"/>
               </a:ext>
             </a:extLst>
           </p:cNvPr>
@@ -9176,7 +9176,7 @@
           <p:cNvPr id="15" name="summary-label-2">
             <a:extLst xmlns:a="http://schemas.openxmlformats.org/drawingml/2006/main">
               <a:ext uri="{FF2B5EF4-FFF2-40B4-BE49-F238E27FC236}">
-                <a16:creationId xmlns:a16="http://schemas.microsoft.com/office/drawing/2014/main" id="{CE5716D7-3970-4E38-B8F0-4622AD0F5E0E}"/>
+                <a16:creationId xmlns:a16="http://schemas.microsoft.com/office/drawing/2014/main" id="{BB836B7C-AE0C-4891-B2A9-72FFB4D89629}"/>
               </a:ext>
             </a:extLst>
           </p:cNvPr>
@@ -9234,7 +9234,7 @@
           <p:cNvPr id="16" name="summary-body-2">
             <a:extLst xmlns:a="http://schemas.openxmlformats.org/drawingml/2006/main">
               <a:ext uri="{FF2B5EF4-FFF2-40B4-BE49-F238E27FC236}">
-                <a16:creationId xmlns:a16="http://schemas.microsoft.com/office/drawing/2014/main" id="{9A115E20-B80F-4766-8D44-88835B840FFD}"/>
+                <a16:creationId xmlns:a16="http://schemas.microsoft.com/office/drawing/2014/main" id="{E74643D9-08F2-4A67-B3BE-1813AF32B3A0}"/>
               </a:ext>
             </a:extLst>
           </p:cNvPr>
@@ -9315,7 +9315,7 @@
           <p:cNvPr id="17" name="summary-rule-2">
             <a:extLst xmlns:a="http://schemas.openxmlformats.org/drawingml/2006/main">
               <a:ext uri="{FF2B5EF4-FFF2-40B4-BE49-F238E27FC236}">
-                <a16:creationId xmlns:a16="http://schemas.microsoft.com/office/drawing/2014/main" id="{A78A4F94-D6EB-427A-914C-E8175D42AA3F}"/>
+                <a16:creationId xmlns:a16="http://schemas.microsoft.com/office/drawing/2014/main" id="{1202E8F5-5E94-4D3E-B973-833F484FEE3A}"/>
               </a:ext>
             </a:extLst>
           </p:cNvPr>
@@ -9346,7 +9346,7 @@
           <p:cNvPr id="18" name="summary-label-3">
             <a:extLst xmlns:a="http://schemas.openxmlformats.org/drawingml/2006/main">
               <a:ext uri="{FF2B5EF4-FFF2-40B4-BE49-F238E27FC236}">
-                <a16:creationId xmlns:a16="http://schemas.microsoft.com/office/drawing/2014/main" id="{64D37FE4-7EF2-46E3-9B69-5C4144A2E38D}"/>
+                <a16:creationId xmlns:a16="http://schemas.microsoft.com/office/drawing/2014/main" id="{0099D4F0-58E4-4ADF-BC80-ABCD2D4E2DF5}"/>
               </a:ext>
             </a:extLst>
           </p:cNvPr>
@@ -9404,7 +9404,7 @@
           <p:cNvPr id="19" name="summary-body-3">
             <a:extLst xmlns:a="http://schemas.openxmlformats.org/drawingml/2006/main">
               <a:ext uri="{FF2B5EF4-FFF2-40B4-BE49-F238E27FC236}">
-                <a16:creationId xmlns:a16="http://schemas.microsoft.com/office/drawing/2014/main" id="{F9DF062A-ABF3-4065-9C14-3B2801F69E66}"/>
+                <a16:creationId xmlns:a16="http://schemas.microsoft.com/office/drawing/2014/main" id="{E9EFB5F9-7A58-4A6A-A28F-390C3BE19584}"/>
               </a:ext>
             </a:extLst>
           </p:cNvPr>
@@ -9462,7 +9462,7 @@
           <p:cNvPr id="20" name="page-reference">
             <a:extLst xmlns:a="http://schemas.openxmlformats.org/drawingml/2006/main">
               <a:ext uri="{FF2B5EF4-FFF2-40B4-BE49-F238E27FC236}">
-                <a16:creationId xmlns:a16="http://schemas.microsoft.com/office/drawing/2014/main" id="{B389EFFE-AC0C-4C71-8344-F41C3763CFA1}"/>
+                <a16:creationId xmlns:a16="http://schemas.microsoft.com/office/drawing/2014/main" id="{644439A9-F5F2-46F6-BEE2-90666D4B8BD7}"/>
               </a:ext>
             </a:extLst>
           </p:cNvPr>
@@ -9518,7 +9518,7 @@
     </p:spTree>
     <p:extLst>
       <p:ext uri="{BB962C8B-B14F-4D97-AF65-F5344CB8AC3E}">
-        <p14:creationId xmlns:p14="http://schemas.microsoft.com/office/powerpoint/2010/main" val="1031412903"/>
+        <p14:creationId xmlns:p14="http://schemas.microsoft.com/office/powerpoint/2010/main" val="1047302278"/>
       </p:ext>
     </p:extLst>
   </p:cSld>
@@ -9549,7 +9549,7 @@
           <p:cNvPr id="14" name="footer-line">
             <a:extLst xmlns:a="http://schemas.openxmlformats.org/drawingml/2006/main">
               <a:ext uri="{FF2B5EF4-FFF2-40B4-BE49-F238E27FC236}">
-                <a16:creationId xmlns:a16="http://schemas.microsoft.com/office/drawing/2014/main" id="{3CE894FC-3721-4586-9789-801E845BDB7D}"/>
+                <a16:creationId xmlns:a16="http://schemas.microsoft.com/office/drawing/2014/main" id="{446C2032-655E-4B81-8E32-16311C705F15}"/>
               </a:ext>
             </a:extLst>
           </p:cNvPr>
@@ -9584,7 +9584,7 @@
           <p:nvPr/>
         </p:nvPicPr>
         <p:blipFill>
-          <a:blip xmlns:r="http://schemas.openxmlformats.org/officeDocument/2006/relationships" xmlns:a="http://schemas.openxmlformats.org/drawingml/2006/main" r:embed="Rea3aa75ae117487f"/>
+          <a:blip xmlns:r="http://schemas.openxmlformats.org/officeDocument/2006/relationships" xmlns:a="http://schemas.openxmlformats.org/drawingml/2006/main" r:embed="Rd2f1a43922a24b9f"/>
           <a:stretch xmlns:a="http://schemas.openxmlformats.org/drawingml/2006/main"/>
         </p:blipFill>
         <p:spPr>
@@ -9602,7 +9602,7 @@
           <p:cNvPr id="3" name="page">
             <a:extLst xmlns:a="http://schemas.openxmlformats.org/drawingml/2006/main">
               <a:ext uri="{FF2B5EF4-FFF2-40B4-BE49-F238E27FC236}">
-                <a16:creationId xmlns:a16="http://schemas.microsoft.com/office/drawing/2014/main" id="{1E80F92A-EDAC-4D63-AE05-4850D87B1FF6}"/>
+                <a16:creationId xmlns:a16="http://schemas.microsoft.com/office/drawing/2014/main" id="{69C9E50D-0943-42A2-9B0E-4D4E65936D9E}"/>
               </a:ext>
             </a:extLst>
           </p:cNvPr>
@@ -9660,7 +9660,7 @@
           <p:cNvPr id="4" name="fictional-disclosure">
             <a:extLst xmlns:a="http://schemas.openxmlformats.org/drawingml/2006/main">
               <a:ext uri="{FF2B5EF4-FFF2-40B4-BE49-F238E27FC236}">
-                <a16:creationId xmlns:a16="http://schemas.microsoft.com/office/drawing/2014/main" id="{10C95FF9-D45F-4944-86D7-D52BAB30ED37}"/>
+                <a16:creationId xmlns:a16="http://schemas.microsoft.com/office/drawing/2014/main" id="{1211F79A-2AC0-493E-A200-9C24B855D393}"/>
               </a:ext>
             </a:extLst>
           </p:cNvPr>
@@ -9718,7 +9718,7 @@
           <p:cNvPr id="5" name="running-chapter-9">
             <a:extLst xmlns:a="http://schemas.openxmlformats.org/drawingml/2006/main">
               <a:ext uri="{FF2B5EF4-FFF2-40B4-BE49-F238E27FC236}">
-                <a16:creationId xmlns:a16="http://schemas.microsoft.com/office/drawing/2014/main" id="{D360E0F9-080C-4200-BE3B-589116DF85C3}"/>
+                <a16:creationId xmlns:a16="http://schemas.microsoft.com/office/drawing/2014/main" id="{D72064A2-18B3-42DD-8470-66A55F779381}"/>
               </a:ext>
             </a:extLst>
           </p:cNvPr>
@@ -9776,7 +9776,7 @@
           <p:cNvPr id="6" name="running-title-9">
             <a:extLst xmlns:a="http://schemas.openxmlformats.org/drawingml/2006/main">
               <a:ext uri="{FF2B5EF4-FFF2-40B4-BE49-F238E27FC236}">
-                <a16:creationId xmlns:a16="http://schemas.microsoft.com/office/drawing/2014/main" id="{4F7D9D26-1D24-453E-8301-C83F3F2ADDCB}"/>
+                <a16:creationId xmlns:a16="http://schemas.microsoft.com/office/drawing/2014/main" id="{4427A6EA-2D8F-4D31-90F3-286B22A79562}"/>
               </a:ext>
             </a:extLst>
           </p:cNvPr>
@@ -9834,7 +9834,7 @@
           <p:cNvPr id="7" name="final-title">
             <a:extLst xmlns:a="http://schemas.openxmlformats.org/drawingml/2006/main">
               <a:ext uri="{FF2B5EF4-FFF2-40B4-BE49-F238E27FC236}">
-                <a16:creationId xmlns:a16="http://schemas.microsoft.com/office/drawing/2014/main" id="{A7746361-7631-4A4C-9252-B8AC4F4EAB70}"/>
+                <a16:creationId xmlns:a16="http://schemas.microsoft.com/office/drawing/2014/main" id="{0C177179-68C8-4EAA-A5F1-2340E3693D51}"/>
               </a:ext>
             </a:extLst>
           </p:cNvPr>
@@ -9915,7 +9915,7 @@
           <p:cNvPr id="8" name="final-author">
             <a:extLst xmlns:a="http://schemas.openxmlformats.org/drawingml/2006/main">
               <a:ext uri="{FF2B5EF4-FFF2-40B4-BE49-F238E27FC236}">
-                <a16:creationId xmlns:a16="http://schemas.microsoft.com/office/drawing/2014/main" id="{12FF9CAC-4DE0-4633-A0C9-D369D9D4BC10}"/>
+                <a16:creationId xmlns:a16="http://schemas.microsoft.com/office/drawing/2014/main" id="{B89FE76A-4F87-4F93-A8EF-9086F8D5E95A}"/>
               </a:ext>
             </a:extLst>
           </p:cNvPr>
@@ -9973,7 +9973,7 @@
           <p:cNvPr id="9" name="takeaway-0">
             <a:extLst xmlns:a="http://schemas.openxmlformats.org/drawingml/2006/main">
               <a:ext uri="{FF2B5EF4-FFF2-40B4-BE49-F238E27FC236}">
-                <a16:creationId xmlns:a16="http://schemas.microsoft.com/office/drawing/2014/main" id="{E98059D4-00AC-4852-B8D8-2C7937C52C2E}"/>
+                <a16:creationId xmlns:a16="http://schemas.microsoft.com/office/drawing/2014/main" id="{DFAB226A-0318-4F76-8707-CF5DEDF1C23C}"/>
               </a:ext>
             </a:extLst>
           </p:cNvPr>
@@ -10031,7 +10031,7 @@
           <p:cNvPr id="10" name="takeaway-1">
             <a:extLst xmlns:a="http://schemas.openxmlformats.org/drawingml/2006/main">
               <a:ext uri="{FF2B5EF4-FFF2-40B4-BE49-F238E27FC236}">
-                <a16:creationId xmlns:a16="http://schemas.microsoft.com/office/drawing/2014/main" id="{D840E0BB-571F-4AD2-9428-3866B71D5464}"/>
+                <a16:creationId xmlns:a16="http://schemas.microsoft.com/office/drawing/2014/main" id="{694536AA-047D-4A00-A483-EAE08592C6DE}"/>
               </a:ext>
             </a:extLst>
           </p:cNvPr>
@@ -10089,7 +10089,7 @@
           <p:cNvPr id="11" name="takeaway-2">
             <a:extLst xmlns:a="http://schemas.openxmlformats.org/drawingml/2006/main">
               <a:ext uri="{FF2B5EF4-FFF2-40B4-BE49-F238E27FC236}">
-                <a16:creationId xmlns:a16="http://schemas.microsoft.com/office/drawing/2014/main" id="{0CCEA9B9-D25F-4758-8A67-B737243E73FB}"/>
+                <a16:creationId xmlns:a16="http://schemas.microsoft.com/office/drawing/2014/main" id="{147BB775-D783-478C-8E1C-8840A0271B44}"/>
               </a:ext>
             </a:extLst>
           </p:cNvPr>
@@ -10147,7 +10147,7 @@
           <p:cNvPr id="12" name="contact">
             <a:extLst xmlns:a="http://schemas.openxmlformats.org/drawingml/2006/main">
               <a:ext uri="{FF2B5EF4-FFF2-40B4-BE49-F238E27FC236}">
-                <a16:creationId xmlns:a16="http://schemas.microsoft.com/office/drawing/2014/main" id="{5ABB64D1-8E32-4EE3-95E5-A584A17B6A3A}"/>
+                <a16:creationId xmlns:a16="http://schemas.microsoft.com/office/drawing/2014/main" id="{4962575A-14F8-4113-9861-08887EEC412F}"/>
               </a:ext>
             </a:extLst>
           </p:cNvPr>
@@ -10205,7 +10205,7 @@
           <p:cNvPr id="13" name="page-reference">
             <a:extLst xmlns:a="http://schemas.openxmlformats.org/drawingml/2006/main">
               <a:ext uri="{FF2B5EF4-FFF2-40B4-BE49-F238E27FC236}">
-                <a16:creationId xmlns:a16="http://schemas.microsoft.com/office/drawing/2014/main" id="{8D1B4663-FB1B-4270-974F-E96984F6C599}"/>
+                <a16:creationId xmlns:a16="http://schemas.microsoft.com/office/drawing/2014/main" id="{2EF928FA-4F5D-4DF9-B446-5C31FD639A7F}"/>
               </a:ext>
             </a:extLst>
           </p:cNvPr>
@@ -10261,7 +10261,7 @@
     </p:spTree>
     <p:extLst>
       <p:ext uri="{BB962C8B-B14F-4D97-AF65-F5344CB8AC3E}">
-        <p14:creationId xmlns:p14="http://schemas.microsoft.com/office/powerpoint/2010/main" val="1350184314"/>
+        <p14:creationId xmlns:p14="http://schemas.microsoft.com/office/powerpoint/2010/main" val="699565791"/>
       </p:ext>
     </p:extLst>
   </p:cSld>

</xml_diff>